<commit_message>
Fix charts, transparency and heading overflow for Canva import
</commit_message>
<xml_diff>
--- a/TradeSim_IIM_Calcutta_Pitch.pptx
+++ b/TradeSim_IIM_Calcutta_Pitch.pptx
@@ -119,1029 +119,6 @@
 </p:presentation>
 </file>
 
-<file path=ppt/charts/chart1.xml><?xml version="1.0" encoding="utf-8"?>
-<c:chartSpace xmlns:c="http://schemas.openxmlformats.org/drawingml/2006/chart" xmlns:a="http://schemas.openxmlformats.org/drawingml/2006/main" xmlns:r="http://schemas.openxmlformats.org/officeDocument/2006/relationships">
-  <c:date1904 val="0"/>
-  <c:roundedCorners val="1"/>
-  <c:chart>
-    <c:autoTitleDeleted val="1"/>
-    <c:plotArea>
-      <c:layout/>
-      <c:barChart>
-        <c:barDir val="col"/>
-        <c:grouping val="stacked"/>
-        <c:varyColors val="0"/>
-        <c:ser>
-          <c:idx val="0"/>
-          <c:order val="0"/>
-          <c:tx>
-            <c:strRef>
-              <c:f>Sheet1!$B$1</c:f>
-              <c:strCache>
-                <c:ptCount val="1"/>
-                <c:pt idx="0">
-                  <c:v>Institutions ₹1.19 Cr</c:v>
-                </c:pt>
-              </c:strCache>
-            </c:strRef>
-          </c:tx>
-          <c:spPr>
-            <a:solidFill>
-              <a:srgbClr val="0F7B4C"/>
-            </a:solidFill>
-            <a:effectLst/>
-          </c:spPr>
-          <c:invertIfNegative val="0"/>
-          <c:dLbls>
-            <c:numFmt formatCode="#,##0" sourceLinked="0"/>
-            <c:txPr>
-              <a:bodyPr/>
-              <a:lstStyle/>
-              <a:p>
-                <a:pPr>
-                  <a:defRPr b="0" i="0" strike="noStrike" sz="1200" u="none">
-                    <a:solidFill>
-                      <a:srgbClr val="000000"/>
-                    </a:solidFill>
-                    <a:latin typeface="Arial"/>
-                  </a:defRPr>
-                </a:pPr>
-              </a:p>
-            </c:txPr>
-            <c:showLegendKey val="0"/>
-            <c:showVal val="0"/>
-            <c:showCatName val="0"/>
-            <c:showSerName val="0"/>
-            <c:showPercent val="0"/>
-            <c:showBubbleSize val="0"/>
-            <c:showLeaderLines val="0"/>
-          </c:dLbls>
-          <c:cat>
-            <c:multiLvlStrRef>
-              <c:f>Sheet1!$A$2:$A$3</c:f>
-              <c:multiLvlStrCache>
-                <c:ptCount val="2"/>
-                <c:lvl>
-                  <c:pt idx="0">
-                    <c:v>Revenue ₹1.45 Cr</c:v>
-                  </c:pt>
-                  <c:pt idx="1">
-                    <c:v>Cost (year 1) ₹1.40 Cr</c:v>
-                  </c:pt>
-                </c:lvl>
-              </c:multiLvlStrCache>
-            </c:multiLvlStrRef>
-          </c:cat>
-          <c:val>
-            <c:numRef>
-              <c:f>Sheet1!$B$2:$B$3</c:f>
-              <c:numCache>
-                <c:formatCode>General</c:formatCode>
-                <c:ptCount val="2"/>
-                <c:pt idx="0">
-                  <c:v>119</c:v>
-                </c:pt>
-                <c:pt idx="1">
-                  <c:v>0</c:v>
-                </c:pt>
-              </c:numCache>
-            </c:numRef>
-          </c:val>
-        </c:ser>
-        <c:ser>
-          <c:idx val="1"/>
-          <c:order val="1"/>
-          <c:tx>
-            <c:strRef>
-              <c:f>Sheet1!$C$1</c:f>
-              <c:strCache>
-                <c:ptCount val="1"/>
-                <c:pt idx="0">
-                  <c:v>Ads ₹15.6 L</c:v>
-                </c:pt>
-              </c:strCache>
-            </c:strRef>
-          </c:tx>
-          <c:spPr>
-            <a:solidFill>
-              <a:srgbClr val="E8A800"/>
-            </a:solidFill>
-            <a:effectLst/>
-          </c:spPr>
-          <c:invertIfNegative val="0"/>
-          <c:dLbls>
-            <c:numFmt formatCode="#,##0" sourceLinked="0"/>
-            <c:txPr>
-              <a:bodyPr/>
-              <a:lstStyle/>
-              <a:p>
-                <a:pPr>
-                  <a:defRPr b="0" i="0" strike="noStrike" sz="1200" u="none">
-                    <a:solidFill>
-                      <a:srgbClr val="000000"/>
-                    </a:solidFill>
-                    <a:latin typeface="Arial"/>
-                  </a:defRPr>
-                </a:pPr>
-              </a:p>
-            </c:txPr>
-            <c:showLegendKey val="0"/>
-            <c:showVal val="0"/>
-            <c:showCatName val="0"/>
-            <c:showSerName val="0"/>
-            <c:showPercent val="0"/>
-            <c:showBubbleSize val="0"/>
-            <c:showLeaderLines val="0"/>
-          </c:dLbls>
-          <c:cat>
-            <c:multiLvlStrRef>
-              <c:f>Sheet1!$A$2:$A$3</c:f>
-              <c:multiLvlStrCache>
-                <c:ptCount val="2"/>
-                <c:lvl>
-                  <c:pt idx="0">
-                    <c:v>Revenue ₹1.45 Cr</c:v>
-                  </c:pt>
-                  <c:pt idx="1">
-                    <c:v>Cost (year 1) ₹1.40 Cr</c:v>
-                  </c:pt>
-                </c:lvl>
-              </c:multiLvlStrCache>
-            </c:multiLvlStrRef>
-          </c:cat>
-          <c:val>
-            <c:numRef>
-              <c:f>Sheet1!$C$2:$C$3</c:f>
-              <c:numCache>
-                <c:formatCode>General</c:formatCode>
-                <c:ptCount val="2"/>
-                <c:pt idx="0">
-                  <c:v>15.6</c:v>
-                </c:pt>
-                <c:pt idx="1">
-                  <c:v>0</c:v>
-                </c:pt>
-              </c:numCache>
-            </c:numRef>
-          </c:val>
-        </c:ser>
-        <c:ser>
-          <c:idx val="2"/>
-          <c:order val="2"/>
-          <c:tx>
-            <c:strRef>
-              <c:f>Sheet1!$D$1</c:f>
-              <c:strCache>
-                <c:ptCount val="1"/>
-                <c:pt idx="0">
-                  <c:v>Paid individuals ₹10 L</c:v>
-                </c:pt>
-              </c:strCache>
-            </c:strRef>
-          </c:tx>
-          <c:spPr>
-            <a:solidFill>
-              <a:srgbClr val="14213D"/>
-            </a:solidFill>
-            <a:effectLst/>
-          </c:spPr>
-          <c:invertIfNegative val="0"/>
-          <c:dLbls>
-            <c:numFmt formatCode="#,##0" sourceLinked="0"/>
-            <c:txPr>
-              <a:bodyPr/>
-              <a:lstStyle/>
-              <a:p>
-                <a:pPr>
-                  <a:defRPr b="0" i="0" strike="noStrike" sz="1200" u="none">
-                    <a:solidFill>
-                      <a:srgbClr val="000000"/>
-                    </a:solidFill>
-                    <a:latin typeface="Arial"/>
-                  </a:defRPr>
-                </a:pPr>
-              </a:p>
-            </c:txPr>
-            <c:showLegendKey val="0"/>
-            <c:showVal val="0"/>
-            <c:showCatName val="0"/>
-            <c:showSerName val="0"/>
-            <c:showPercent val="0"/>
-            <c:showBubbleSize val="0"/>
-            <c:showLeaderLines val="0"/>
-          </c:dLbls>
-          <c:cat>
-            <c:multiLvlStrRef>
-              <c:f>Sheet1!$A$2:$A$3</c:f>
-              <c:multiLvlStrCache>
-                <c:ptCount val="2"/>
-                <c:lvl>
-                  <c:pt idx="0">
-                    <c:v>Revenue ₹1.45 Cr</c:v>
-                  </c:pt>
-                  <c:pt idx="1">
-                    <c:v>Cost (year 1) ₹1.40 Cr</c:v>
-                  </c:pt>
-                </c:lvl>
-              </c:multiLvlStrCache>
-            </c:multiLvlStrRef>
-          </c:cat>
-          <c:val>
-            <c:numRef>
-              <c:f>Sheet1!$D$2:$D$3</c:f>
-              <c:numCache>
-                <c:formatCode>General</c:formatCode>
-                <c:ptCount val="2"/>
-                <c:pt idx="0">
-                  <c:v>10</c:v>
-                </c:pt>
-                <c:pt idx="1">
-                  <c:v>0</c:v>
-                </c:pt>
-              </c:numCache>
-            </c:numRef>
-          </c:val>
-        </c:ser>
-        <c:ser>
-          <c:idx val="3"/>
-          <c:order val="3"/>
-          <c:tx>
-            <c:strRef>
-              <c:f>Sheet1!$E$1</c:f>
-              <c:strCache>
-                <c:ptCount val="1"/>
-                <c:pt idx="0">
-                  <c:v>Team ₹42 L</c:v>
-                </c:pt>
-              </c:strCache>
-            </c:strRef>
-          </c:tx>
-          <c:spPr>
-            <a:solidFill>
-              <a:srgbClr val="C1272D"/>
-            </a:solidFill>
-            <a:effectLst/>
-          </c:spPr>
-          <c:invertIfNegative val="0"/>
-          <c:dLbls>
-            <c:numFmt formatCode="#,##0" sourceLinked="0"/>
-            <c:txPr>
-              <a:bodyPr/>
-              <a:lstStyle/>
-              <a:p>
-                <a:pPr>
-                  <a:defRPr b="0" i="0" strike="noStrike" sz="1200" u="none">
-                    <a:solidFill>
-                      <a:srgbClr val="000000"/>
-                    </a:solidFill>
-                    <a:latin typeface="Arial"/>
-                  </a:defRPr>
-                </a:pPr>
-              </a:p>
-            </c:txPr>
-            <c:showLegendKey val="0"/>
-            <c:showVal val="0"/>
-            <c:showCatName val="0"/>
-            <c:showSerName val="0"/>
-            <c:showPercent val="0"/>
-            <c:showBubbleSize val="0"/>
-            <c:showLeaderLines val="0"/>
-          </c:dLbls>
-          <c:cat>
-            <c:multiLvlStrRef>
-              <c:f>Sheet1!$A$2:$A$3</c:f>
-              <c:multiLvlStrCache>
-                <c:ptCount val="2"/>
-                <c:lvl>
-                  <c:pt idx="0">
-                    <c:v>Revenue ₹1.45 Cr</c:v>
-                  </c:pt>
-                  <c:pt idx="1">
-                    <c:v>Cost (year 1) ₹1.40 Cr</c:v>
-                  </c:pt>
-                </c:lvl>
-              </c:multiLvlStrCache>
-            </c:multiLvlStrRef>
-          </c:cat>
-          <c:val>
-            <c:numRef>
-              <c:f>Sheet1!$E$2:$E$3</c:f>
-              <c:numCache>
-                <c:formatCode>General</c:formatCode>
-                <c:ptCount val="2"/>
-                <c:pt idx="0">
-                  <c:v>0</c:v>
-                </c:pt>
-                <c:pt idx="1">
-                  <c:v>42</c:v>
-                </c:pt>
-              </c:numCache>
-            </c:numRef>
-          </c:val>
-        </c:ser>
-        <c:ser>
-          <c:idx val="4"/>
-          <c:order val="4"/>
-          <c:tx>
-            <c:strRef>
-              <c:f>Sheet1!$F$1</c:f>
-              <c:strCache>
-                <c:ptCount val="1"/>
-                <c:pt idx="0">
-                  <c:v>Sales ₹48 L</c:v>
-                </c:pt>
-              </c:strCache>
-            </c:strRef>
-          </c:tx>
-          <c:spPr>
-            <a:solidFill>
-              <a:srgbClr val="D9534F"/>
-            </a:solidFill>
-            <a:effectLst/>
-          </c:spPr>
-          <c:invertIfNegative val="0"/>
-          <c:dLbls>
-            <c:numFmt formatCode="#,##0" sourceLinked="0"/>
-            <c:txPr>
-              <a:bodyPr/>
-              <a:lstStyle/>
-              <a:p>
-                <a:pPr>
-                  <a:defRPr b="0" i="0" strike="noStrike" sz="1200" u="none">
-                    <a:solidFill>
-                      <a:srgbClr val="000000"/>
-                    </a:solidFill>
-                    <a:latin typeface="Arial"/>
-                  </a:defRPr>
-                </a:pPr>
-              </a:p>
-            </c:txPr>
-            <c:showLegendKey val="0"/>
-            <c:showVal val="0"/>
-            <c:showCatName val="0"/>
-            <c:showSerName val="0"/>
-            <c:showPercent val="0"/>
-            <c:showBubbleSize val="0"/>
-            <c:showLeaderLines val="0"/>
-          </c:dLbls>
-          <c:cat>
-            <c:multiLvlStrRef>
-              <c:f>Sheet1!$A$2:$A$3</c:f>
-              <c:multiLvlStrCache>
-                <c:ptCount val="2"/>
-                <c:lvl>
-                  <c:pt idx="0">
-                    <c:v>Revenue ₹1.45 Cr</c:v>
-                  </c:pt>
-                  <c:pt idx="1">
-                    <c:v>Cost (year 1) ₹1.40 Cr</c:v>
-                  </c:pt>
-                </c:lvl>
-              </c:multiLvlStrCache>
-            </c:multiLvlStrRef>
-          </c:cat>
-          <c:val>
-            <c:numRef>
-              <c:f>Sheet1!$F$2:$F$3</c:f>
-              <c:numCache>
-                <c:formatCode>General</c:formatCode>
-                <c:ptCount val="2"/>
-                <c:pt idx="0">
-                  <c:v>0</c:v>
-                </c:pt>
-                <c:pt idx="1">
-                  <c:v>48</c:v>
-                </c:pt>
-              </c:numCache>
-            </c:numRef>
-          </c:val>
-        </c:ser>
-        <c:ser>
-          <c:idx val="5"/>
-          <c:order val="5"/>
-          <c:tx>
-            <c:strRef>
-              <c:f>Sheet1!$G$1</c:f>
-              <c:strCache>
-                <c:ptCount val="1"/>
-                <c:pt idx="0">
-                  <c:v>Cloud ₹30 L</c:v>
-                </c:pt>
-              </c:strCache>
-            </c:strRef>
-          </c:tx>
-          <c:spPr>
-            <a:solidFill>
-              <a:srgbClr val="E8807C"/>
-            </a:solidFill>
-            <a:effectLst/>
-          </c:spPr>
-          <c:invertIfNegative val="0"/>
-          <c:dLbls>
-            <c:numFmt formatCode="#,##0" sourceLinked="0"/>
-            <c:txPr>
-              <a:bodyPr/>
-              <a:lstStyle/>
-              <a:p>
-                <a:pPr>
-                  <a:defRPr b="0" i="0" strike="noStrike" sz="1200" u="none">
-                    <a:solidFill>
-                      <a:srgbClr val="000000"/>
-                    </a:solidFill>
-                    <a:latin typeface="Arial"/>
-                  </a:defRPr>
-                </a:pPr>
-              </a:p>
-            </c:txPr>
-            <c:showLegendKey val="0"/>
-            <c:showVal val="0"/>
-            <c:showCatName val="0"/>
-            <c:showSerName val="0"/>
-            <c:showPercent val="0"/>
-            <c:showBubbleSize val="0"/>
-            <c:showLeaderLines val="0"/>
-          </c:dLbls>
-          <c:cat>
-            <c:multiLvlStrRef>
-              <c:f>Sheet1!$A$2:$A$3</c:f>
-              <c:multiLvlStrCache>
-                <c:ptCount val="2"/>
-                <c:lvl>
-                  <c:pt idx="0">
-                    <c:v>Revenue ₹1.45 Cr</c:v>
-                  </c:pt>
-                  <c:pt idx="1">
-                    <c:v>Cost (year 1) ₹1.40 Cr</c:v>
-                  </c:pt>
-                </c:lvl>
-              </c:multiLvlStrCache>
-            </c:multiLvlStrRef>
-          </c:cat>
-          <c:val>
-            <c:numRef>
-              <c:f>Sheet1!$G$2:$G$3</c:f>
-              <c:numCache>
-                <c:formatCode>General</c:formatCode>
-                <c:ptCount val="2"/>
-                <c:pt idx="0">
-                  <c:v>0</c:v>
-                </c:pt>
-                <c:pt idx="1">
-                  <c:v>30</c:v>
-                </c:pt>
-              </c:numCache>
-            </c:numRef>
-          </c:val>
-        </c:ser>
-        <c:ser>
-          <c:idx val="6"/>
-          <c:order val="6"/>
-          <c:tx>
-            <c:strRef>
-              <c:f>Sheet1!$H$1</c:f>
-              <c:strCache>
-                <c:ptCount val="1"/>
-                <c:pt idx="0">
-                  <c:v>Data ₹10 L</c:v>
-                </c:pt>
-              </c:strCache>
-            </c:strRef>
-          </c:tx>
-          <c:spPr>
-            <a:solidFill>
-              <a:srgbClr val="F2ADAA"/>
-            </a:solidFill>
-            <a:effectLst/>
-          </c:spPr>
-          <c:invertIfNegative val="0"/>
-          <c:dLbls>
-            <c:numFmt formatCode="#,##0" sourceLinked="0"/>
-            <c:txPr>
-              <a:bodyPr/>
-              <a:lstStyle/>
-              <a:p>
-                <a:pPr>
-                  <a:defRPr b="0" i="0" strike="noStrike" sz="1200" u="none">
-                    <a:solidFill>
-                      <a:srgbClr val="000000"/>
-                    </a:solidFill>
-                    <a:latin typeface="Arial"/>
-                  </a:defRPr>
-                </a:pPr>
-              </a:p>
-            </c:txPr>
-            <c:showLegendKey val="0"/>
-            <c:showVal val="0"/>
-            <c:showCatName val="0"/>
-            <c:showSerName val="0"/>
-            <c:showPercent val="0"/>
-            <c:showBubbleSize val="0"/>
-            <c:showLeaderLines val="0"/>
-          </c:dLbls>
-          <c:cat>
-            <c:multiLvlStrRef>
-              <c:f>Sheet1!$A$2:$A$3</c:f>
-              <c:multiLvlStrCache>
-                <c:ptCount val="2"/>
-                <c:lvl>
-                  <c:pt idx="0">
-                    <c:v>Revenue ₹1.45 Cr</c:v>
-                  </c:pt>
-                  <c:pt idx="1">
-                    <c:v>Cost (year 1) ₹1.40 Cr</c:v>
-                  </c:pt>
-                </c:lvl>
-              </c:multiLvlStrCache>
-            </c:multiLvlStrRef>
-          </c:cat>
-          <c:val>
-            <c:numRef>
-              <c:f>Sheet1!$H$2:$H$3</c:f>
-              <c:numCache>
-                <c:formatCode>General</c:formatCode>
-                <c:ptCount val="2"/>
-                <c:pt idx="0">
-                  <c:v>0</c:v>
-                </c:pt>
-                <c:pt idx="1">
-                  <c:v>10</c:v>
-                </c:pt>
-              </c:numCache>
-            </c:numRef>
-          </c:val>
-        </c:ser>
-        <c:ser>
-          <c:idx val="7"/>
-          <c:order val="7"/>
-          <c:tx>
-            <c:strRef>
-              <c:f>Sheet1!$I$1</c:f>
-              <c:strCache>
-                <c:ptCount val="1"/>
-                <c:pt idx="0">
-                  <c:v>Ops ₹10 L</c:v>
-                </c:pt>
-              </c:strCache>
-            </c:strRef>
-          </c:tx>
-          <c:spPr>
-            <a:solidFill>
-              <a:srgbClr val="F8D7D5"/>
-            </a:solidFill>
-            <a:effectLst/>
-          </c:spPr>
-          <c:invertIfNegative val="0"/>
-          <c:dLbls>
-            <c:numFmt formatCode="#,##0" sourceLinked="0"/>
-            <c:txPr>
-              <a:bodyPr/>
-              <a:lstStyle/>
-              <a:p>
-                <a:pPr>
-                  <a:defRPr b="0" i="0" strike="noStrike" sz="1200" u="none">
-                    <a:solidFill>
-                      <a:srgbClr val="000000"/>
-                    </a:solidFill>
-                    <a:latin typeface="Arial"/>
-                  </a:defRPr>
-                </a:pPr>
-              </a:p>
-            </c:txPr>
-            <c:showLegendKey val="0"/>
-            <c:showVal val="0"/>
-            <c:showCatName val="0"/>
-            <c:showSerName val="0"/>
-            <c:showPercent val="0"/>
-            <c:showBubbleSize val="0"/>
-            <c:showLeaderLines val="0"/>
-          </c:dLbls>
-          <c:cat>
-            <c:multiLvlStrRef>
-              <c:f>Sheet1!$A$2:$A$3</c:f>
-              <c:multiLvlStrCache>
-                <c:ptCount val="2"/>
-                <c:lvl>
-                  <c:pt idx="0">
-                    <c:v>Revenue ₹1.45 Cr</c:v>
-                  </c:pt>
-                  <c:pt idx="1">
-                    <c:v>Cost (year 1) ₹1.40 Cr</c:v>
-                  </c:pt>
-                </c:lvl>
-              </c:multiLvlStrCache>
-            </c:multiLvlStrRef>
-          </c:cat>
-          <c:val>
-            <c:numRef>
-              <c:f>Sheet1!$I$2:$I$3</c:f>
-              <c:numCache>
-                <c:formatCode>General</c:formatCode>
-                <c:ptCount val="2"/>
-                <c:pt idx="0">
-                  <c:v>0</c:v>
-                </c:pt>
-                <c:pt idx="1">
-                  <c:v>10</c:v>
-                </c:pt>
-              </c:numCache>
-            </c:numRef>
-          </c:val>
-        </c:ser>
-        <c:dLbls>
-          <c:numFmt formatCode="#,##0" sourceLinked="0"/>
-          <c:txPr>
-            <a:bodyPr/>
-            <a:lstStyle/>
-            <a:p>
-              <a:pPr>
-                <a:defRPr b="0" i="0" strike="noStrike" sz="1200" u="none">
-                  <a:solidFill>
-                    <a:srgbClr val="000000"/>
-                  </a:solidFill>
-                  <a:latin typeface="Arial"/>
-                </a:defRPr>
-              </a:pPr>
-            </a:p>
-          </c:txPr>
-          <c:showLegendKey val="0"/>
-          <c:showVal val="0"/>
-          <c:showCatName val="0"/>
-          <c:showSerName val="0"/>
-          <c:showPercent val="0"/>
-          <c:showBubbleSize val="0"/>
-          <c:showLeaderLines val="0"/>
-        </c:dLbls>
-        <c:gapWidth val="60"/>
-        <c:overlap val="100"/>
-        <c:axId val="2094734554"/>
-        <c:axId val="2094734552"/>
-        <c:axId val="2094734556"/>
-      </c:barChart>
-      <c:catAx>
-        <c:axId val="2094734554"/>
-        <c:scaling>
-          <c:orientation val="minMax"/>
-        </c:scaling>
-        <c:delete val="0"/>
-        <c:axPos val="b"/>
-        <c:numFmt formatCode="General" sourceLinked="1"/>
-        <c:majorTickMark val="out"/>
-        <c:minorTickMark val="none"/>
-        <c:tickLblPos val="low"/>
-        <c:spPr>
-          <a:ln w="12700" cap="flat">
-            <a:solidFill>
-              <a:srgbClr val="888888"/>
-            </a:solidFill>
-            <a:prstDash val="solid"/>
-            <a:round/>
-          </a:ln>
-        </c:spPr>
-        <c:txPr>
-          <a:bodyPr/>
-          <a:lstStyle/>
-          <a:p>
-            <a:pPr>
-              <a:defRPr sz="1300" b="1" i="0" u="none" strike="noStrike">
-                <a:solidFill>
-                  <a:srgbClr val="14213D"/>
-                </a:solidFill>
-                <a:latin typeface="Calibri"/>
-              </a:defRPr>
-            </a:pPr>
-            <a:endParaRPr lang="en-US"/>
-          </a:p>
-        </c:txPr>
-        <c:crossAx val="2094734552"/>
-        <c:crosses val="autoZero"/>
-        <c:auto val="1"/>
-        <c:lblAlgn val="ctr"/>
-        <c:noMultiLvlLbl val="1"/>
-      </c:catAx>
-      <c:valAx>
-        <c:axId val="2094734552"/>
-        <c:scaling>
-          <c:orientation val="minMax"/>
-        </c:scaling>
-        <c:delete val="1"/>
-        <c:axPos val="l"/>
-        <c:numFmt formatCode="General" sourceLinked="0"/>
-        <c:majorTickMark val="out"/>
-        <c:minorTickMark val="none"/>
-        <c:tickLblPos val="nextTo"/>
-        <c:spPr>
-          <a:ln w="12700" cap="flat">
-            <a:solidFill>
-              <a:srgbClr val="888888"/>
-            </a:solidFill>
-            <a:prstDash val="solid"/>
-            <a:round/>
-          </a:ln>
-        </c:spPr>
-        <c:txPr>
-          <a:bodyPr/>
-          <a:lstStyle/>
-          <a:p>
-            <a:pPr>
-              <a:defRPr sz="1200" b="0" i="0" u="none" strike="noStrike">
-                <a:solidFill>
-                  <a:srgbClr val="000000"/>
-                </a:solidFill>
-                <a:latin typeface="Arial"/>
-              </a:defRPr>
-            </a:pPr>
-            <a:endParaRPr lang="en-US"/>
-          </a:p>
-        </c:txPr>
-        <c:crossAx val="2094734554"/>
-        <c:crosses val="autoZero"/>
-        <c:crossBetween val="between"/>
-      </c:valAx>
-      <c:spPr>
-        <a:solidFill>
-          <a:srgbClr val="FFF7DC"/>
-        </a:solidFill>
-        <a:ln>
-          <a:noFill/>
-        </a:ln>
-        <a:effectLst/>
-      </c:spPr>
-    </c:plotArea>
-    <c:legend>
-      <c:legendPos val="r"/>
-      <c:overlay val="0"/>
-      <c:txPr>
-        <a:bodyPr/>
-        <a:lstStyle/>
-        <a:p>
-          <a:pPr>
-            <a:defRPr sz="1100">
-              <a:solidFill>
-                <a:srgbClr val="14213D"/>
-              </a:solidFill>
-              <a:latin typeface="Calibri"/>
-              <a:cs typeface="Calibri"/>
-            </a:defRPr>
-          </a:pPr>
-          <a:endParaRPr lang="en-US"/>
-        </a:p>
-      </c:txPr>
-    </c:legend>
-    <c:plotVisOnly val="1"/>
-    <c:dispBlanksAs val="span"/>
-  </c:chart>
-  <c:spPr>
-    <a:solidFill>
-      <a:srgbClr val="FFF7DC"/>
-    </a:solidFill>
-    <a:ln>
-      <a:noFill/>
-    </a:ln>
-    <a:effectLst/>
-  </c:spPr>
-  <c:externalData r:id="rId1">
-    <c:autoUpdate val="0"/>
-  </c:externalData>
-</c:chartSpace>
-</file>
-
-<file path=ppt/charts/chart2.xml><?xml version="1.0" encoding="utf-8"?>
-<c:chartSpace xmlns:c="http://schemas.openxmlformats.org/drawingml/2006/chart" xmlns:a="http://schemas.openxmlformats.org/drawingml/2006/main" xmlns:r="http://schemas.openxmlformats.org/officeDocument/2006/relationships">
-  <c:date1904 val="0"/>
-  <c:roundedCorners val="1"/>
-  <c:chart>
-    <c:autoTitleDeleted val="1"/>
-    <c:plotArea>
-      <c:layout/>
-      <c:areaChart>
-        <c:varyColors val="0"/>
-        <c:ser>
-          <c:idx val="0"/>
-          <c:order val="0"/>
-          <c:tx>
-            <c:strRef>
-              <c:f>Sheet1!$B$1</c:f>
-              <c:strCache>
-                <c:ptCount val="1"/>
-                <c:pt idx="0">
-                  <c:v>Users</c:v>
-                </c:pt>
-              </c:strCache>
-            </c:strRef>
-          </c:tx>
-          <c:spPr>
-            <a:solidFill>
-              <a:srgbClr val="0F7B4C">
-                <a:alpha val="35000"/>
-              </a:srgbClr>
-            </a:solidFill>
-            <a:effectLst/>
-          </c:spPr>
-          <c:invertIfNegative val="0"/>
-          <c:dLbls>
-            <c:numFmt formatCode="#,##0" sourceLinked="0"/>
-            <c:txPr>
-              <a:bodyPr/>
-              <a:lstStyle/>
-              <a:p>
-                <a:pPr>
-                  <a:defRPr b="1" i="0" strike="noStrike" sz="1600" u="none">
-                    <a:solidFill>
-                      <a:srgbClr val="14213D"/>
-                    </a:solidFill>
-                    <a:latin typeface="Arial"/>
-                  </a:defRPr>
-                </a:pPr>
-              </a:p>
-            </c:txPr>
-            <c:showLegendKey val="0"/>
-            <c:showVal val="1"/>
-            <c:showCatName val="0"/>
-            <c:showSerName val="0"/>
-            <c:showPercent val="0"/>
-            <c:showBubbleSize val="0"/>
-            <c:showLeaderLines val="0"/>
-          </c:dLbls>
-          <c:cat>
-            <c:multiLvlStrRef>
-              <c:f>Sheet1!$A$2:$A$5</c:f>
-              <c:multiLvlStrCache>
-                <c:ptCount val="4"/>
-                <c:lvl>
-                  <c:pt idx="0">
-                    <c:v>2026 pilot</c:v>
-                  </c:pt>
-                  <c:pt idx="1">
-                    <c:v>Year 1</c:v>
-                  </c:pt>
-                  <c:pt idx="2">
-                    <c:v>Year 2</c:v>
-                  </c:pt>
-                  <c:pt idx="3">
-                    <c:v>Year 3</c:v>
-                  </c:pt>
-                </c:lvl>
-              </c:multiLvlStrCache>
-            </c:multiLvlStrRef>
-          </c:cat>
-          <c:val>
-            <c:numRef>
-              <c:f>Sheet1!$B$2:$B$5</c:f>
-              <c:numCache>
-                <c:formatCode>General</c:formatCode>
-                <c:ptCount val="4"/>
-                <c:pt idx="0">
-                  <c:v>100</c:v>
-                </c:pt>
-                <c:pt idx="1">
-                  <c:v>100000</c:v>
-                </c:pt>
-                <c:pt idx="2">
-                  <c:v>250000</c:v>
-                </c:pt>
-                <c:pt idx="3">
-                  <c:v>500000</c:v>
-                </c:pt>
-              </c:numCache>
-            </c:numRef>
-          </c:val>
-        </c:ser>
-        <c:dLbls>
-          <c:numFmt formatCode="#,##0" sourceLinked="0"/>
-          <c:txPr>
-            <a:bodyPr/>
-            <a:lstStyle/>
-            <a:p>
-              <a:pPr>
-                <a:defRPr b="1" i="0" strike="noStrike" sz="1600" u="none">
-                  <a:solidFill>
-                    <a:srgbClr val="14213D"/>
-                  </a:solidFill>
-                  <a:latin typeface="Arial"/>
-                </a:defRPr>
-              </a:pPr>
-            </a:p>
-          </c:txPr>
-          <c:showLegendKey val="0"/>
-          <c:showVal val="1"/>
-          <c:showCatName val="0"/>
-          <c:showSerName val="0"/>
-          <c:showPercent val="0"/>
-          <c:showBubbleSize val="0"/>
-          <c:showLeaderLines val="0"/>
-        </c:dLbls>
-        <c:axId val="2094734554"/>
-        <c:axId val="2094734552"/>
-        <c:axId val="2094734556"/>
-      </c:areaChart>
-      <c:catAx>
-        <c:axId val="2094734554"/>
-        <c:scaling>
-          <c:orientation val="minMax"/>
-        </c:scaling>
-        <c:delete val="0"/>
-        <c:axPos val="b"/>
-        <c:numFmt formatCode="General" sourceLinked="1"/>
-        <c:majorTickMark val="out"/>
-        <c:minorTickMark val="none"/>
-        <c:tickLblPos val="low"/>
-        <c:spPr>
-          <a:ln w="12700" cap="flat">
-            <a:solidFill>
-              <a:srgbClr val="888888"/>
-            </a:solidFill>
-            <a:prstDash val="solid"/>
-            <a:round/>
-          </a:ln>
-        </c:spPr>
-        <c:txPr>
-          <a:bodyPr/>
-          <a:lstStyle/>
-          <a:p>
-            <a:pPr>
-              <a:defRPr sz="1400" b="1" i="0" u="none" strike="noStrike">
-                <a:solidFill>
-                  <a:srgbClr val="14213D"/>
-                </a:solidFill>
-                <a:latin typeface="Arial"/>
-              </a:defRPr>
-            </a:pPr>
-            <a:endParaRPr lang="en-US"/>
-          </a:p>
-        </c:txPr>
-        <c:crossAx val="2094734552"/>
-        <c:crosses val="autoZero"/>
-        <c:auto val="1"/>
-        <c:lblAlgn val="ctr"/>
-        <c:noMultiLvlLbl val="1"/>
-      </c:catAx>
-      <c:valAx>
-        <c:axId val="2094734552"/>
-        <c:scaling>
-          <c:orientation val="minMax"/>
-        </c:scaling>
-        <c:delete val="1"/>
-        <c:axPos val="l"/>
-        <c:numFmt formatCode="General" sourceLinked="0"/>
-        <c:majorTickMark val="out"/>
-        <c:minorTickMark val="none"/>
-        <c:tickLblPos val="nextTo"/>
-        <c:spPr>
-          <a:ln w="12700" cap="flat">
-            <a:solidFill>
-              <a:srgbClr val="888888"/>
-            </a:solidFill>
-            <a:prstDash val="solid"/>
-            <a:round/>
-          </a:ln>
-        </c:spPr>
-        <c:txPr>
-          <a:bodyPr/>
-          <a:lstStyle/>
-          <a:p>
-            <a:pPr>
-              <a:defRPr sz="1200" b="0" i="0" u="none" strike="noStrike">
-                <a:solidFill>
-                  <a:srgbClr val="000000"/>
-                </a:solidFill>
-                <a:latin typeface="Arial"/>
-              </a:defRPr>
-            </a:pPr>
-            <a:endParaRPr lang="en-US"/>
-          </a:p>
-        </c:txPr>
-        <c:crossAx val="2094734554"/>
-        <c:crosses val="autoZero"/>
-        <c:crossBetween val="between"/>
-      </c:valAx>
-      <c:spPr>
-        <a:solidFill>
-          <a:srgbClr val="FFF7DC"/>
-        </a:solidFill>
-        <a:ln>
-          <a:noFill/>
-        </a:ln>
-        <a:effectLst/>
-      </c:spPr>
-    </c:plotArea>
-    <c:plotVisOnly val="1"/>
-    <c:dispBlanksAs val="span"/>
-  </c:chart>
-  <c:spPr>
-    <a:solidFill>
-      <a:srgbClr val="FFF7DC"/>
-    </a:solidFill>
-    <a:ln>
-      <a:noFill/>
-    </a:ln>
-    <a:effectLst/>
-  </c:spPr>
-  <c:externalData r:id="rId1">
-    <c:autoUpdate val="0"/>
-  </c:externalData>
-</c:chartSpace>
-</file>
-
 <file path=ppt/notesMasters/notesMaster1.xml><?xml version="1.0" encoding="utf-8"?>
 <p:notesMaster xmlns:a="http://schemas.openxmlformats.org/drawingml/2006/main" xmlns:r="http://schemas.openxmlformats.org/officeDocument/2006/relationships" xmlns:p="http://schemas.openxmlformats.org/presentationml/2006/main">
   <p:cSld>
@@ -3079,7 +2056,9 @@
           <a:noFill/>
           <a:ln w="44450">
             <a:solidFill>
-              <a:srgbClr val="0F7B4C"/>
+              <a:srgbClr val="0F7B4C">
+                <a:alpha val="40000"/>
+              </a:srgbClr>
             </a:solidFill>
             <a:prstDash val="solid"/>
           </a:ln>
@@ -3102,7 +2081,9 @@
           <a:noFill/>
           <a:ln w="44450">
             <a:solidFill>
-              <a:srgbClr val="0F7B4C"/>
+              <a:srgbClr val="0F7B4C">
+                <a:alpha val="40000"/>
+              </a:srgbClr>
             </a:solidFill>
             <a:prstDash val="solid"/>
           </a:ln>
@@ -3125,7 +2106,9 @@
           <a:noFill/>
           <a:ln w="44450">
             <a:solidFill>
-              <a:srgbClr val="0F7B4C"/>
+              <a:srgbClr val="0F7B4C">
+                <a:alpha val="40000"/>
+              </a:srgbClr>
             </a:solidFill>
             <a:prstDash val="solid"/>
           </a:ln>
@@ -3148,7 +2131,9 @@
           <a:noFill/>
           <a:ln w="44450">
             <a:solidFill>
-              <a:srgbClr val="0F7B4C"/>
+              <a:srgbClr val="0F7B4C">
+                <a:alpha val="40000"/>
+              </a:srgbClr>
             </a:solidFill>
             <a:prstDash val="solid"/>
           </a:ln>
@@ -3171,7 +2156,9 @@
           <a:noFill/>
           <a:ln w="44450">
             <a:solidFill>
-              <a:srgbClr val="0F7B4C"/>
+              <a:srgbClr val="0F7B4C">
+                <a:alpha val="40000"/>
+              </a:srgbClr>
             </a:solidFill>
             <a:prstDash val="solid"/>
           </a:ln>
@@ -3194,7 +2181,9 @@
           <a:noFill/>
           <a:ln w="44450">
             <a:solidFill>
-              <a:srgbClr val="0F7B4C"/>
+              <a:srgbClr val="0F7B4C">
+                <a:alpha val="40000"/>
+              </a:srgbClr>
             </a:solidFill>
             <a:prstDash val="solid"/>
           </a:ln>
@@ -3217,7 +2206,9 @@
           <a:noFill/>
           <a:ln w="44450">
             <a:solidFill>
-              <a:srgbClr val="0F7B4C"/>
+              <a:srgbClr val="0F7B4C">
+                <a:alpha val="40000"/>
+              </a:srgbClr>
             </a:solidFill>
             <a:prstDash val="solid"/>
           </a:ln>
@@ -3240,7 +2231,9 @@
           <a:noFill/>
           <a:ln w="44450">
             <a:solidFill>
-              <a:srgbClr val="0F7B4C"/>
+              <a:srgbClr val="0F7B4C">
+                <a:alpha val="40000"/>
+              </a:srgbClr>
             </a:solidFill>
             <a:prstDash val="solid"/>
           </a:ln>
@@ -3263,7 +2256,9 @@
           <a:noFill/>
           <a:ln w="44450">
             <a:solidFill>
-              <a:srgbClr val="0F7B4C"/>
+              <a:srgbClr val="0F7B4C">
+                <a:alpha val="40000"/>
+              </a:srgbClr>
             </a:solidFill>
             <a:prstDash val="solid"/>
           </a:ln>
@@ -3286,7 +2281,9 @@
           <a:noFill/>
           <a:ln w="44450">
             <a:solidFill>
-              <a:srgbClr val="0F7B4C"/>
+              <a:srgbClr val="0F7B4C">
+                <a:alpha val="40000"/>
+              </a:srgbClr>
             </a:solidFill>
             <a:prstDash val="solid"/>
           </a:ln>
@@ -3309,7 +2306,9 @@
           <a:noFill/>
           <a:ln w="44450">
             <a:solidFill>
-              <a:srgbClr val="0F7B4C"/>
+              <a:srgbClr val="0F7B4C">
+                <a:alpha val="40000"/>
+              </a:srgbClr>
             </a:solidFill>
             <a:prstDash val="solid"/>
           </a:ln>
@@ -3332,7 +2331,9 @@
           <a:noFill/>
           <a:ln w="44450">
             <a:solidFill>
-              <a:srgbClr val="0F7B4C"/>
+              <a:srgbClr val="0F7B4C">
+                <a:alpha val="40000"/>
+              </a:srgbClr>
             </a:solidFill>
             <a:prstDash val="solid"/>
           </a:ln>
@@ -3355,7 +2356,9 @@
           <a:noFill/>
           <a:ln w="44450">
             <a:solidFill>
-              <a:srgbClr val="0F7B4C"/>
+              <a:srgbClr val="0F7B4C">
+                <a:alpha val="40000"/>
+              </a:srgbClr>
             </a:solidFill>
             <a:prstDash val="solid"/>
           </a:ln>
@@ -4043,44 +3046,1023 @@
           </a:p>
         </p:txBody>
       </p:sp>
-      <p:graphicFrame>
-        <p:nvGraphicFramePr>
-          <p:cNvPr id="8" name="Chart 0" descr=""/>
-          <p:cNvGraphicFramePr/>
-          <p:nvPr/>
-        </p:nvGraphicFramePr>
-        <p:xfrm>
-          <a:off x="812800" y="2413000"/>
-          <a:ext cx="10566400" cy="3429000"/>
-        </p:xfrm>
-        <a:graphic xmlns:a="http://schemas.openxmlformats.org/drawingml/2006/main">
-          <a:graphicData uri="http://schemas.openxmlformats.org/drawingml/2006/chart">
-            <c:chart xmlns:c="http://schemas.openxmlformats.org/drawingml/2006/chart" r:id="rId3"/>
-          </a:graphicData>
-        </a:graphic>
-      </p:graphicFrame>
-      <p:sp>
-        <p:nvSpPr>
-          <p:cNvPr id="9" name="Text 3"/>
-          <p:cNvSpPr txBox="1"/>
-          <p:nvPr/>
-        </p:nvSpPr>
-        <p:spPr>
-          <a:xfrm>
-            <a:off x="3048000" y="4381500"/>
-            <a:ext cx="2032000" cy="215900"/>
-          </a:xfrm>
-          <a:prstGeom prst="rect">
-            <a:avLst/>
-          </a:prstGeom>
-          <a:noFill/>
-          <a:ln/>
-        </p:spPr>
-        <p:txBody>
-          <a:bodyPr wrap="square" lIns="0" tIns="0" rIns="0" bIns="0" rtlCol="0" anchor="t"/>
-          <a:lstStyle/>
-          <a:p>
-            <a:pPr algn="ctr" indent="0" marL="0">
+      <p:sp>
+        <p:nvSpPr>
+          <p:cNvPr id="8" name="Shape 3"/>
+          <p:cNvSpPr/>
+          <p:nvPr/>
+        </p:nvSpPr>
+        <p:spPr>
+          <a:xfrm flipV="1">
+            <a:off x="1447800" y="5705504"/>
+            <a:ext cx="365639" cy="9496"/>
+          </a:xfrm>
+          <a:prstGeom prst="line">
+            <a:avLst/>
+          </a:prstGeom>
+          <a:noFill/>
+          <a:ln w="50800">
+            <a:solidFill>
+              <a:srgbClr val="0F7B4C"/>
+            </a:solidFill>
+            <a:prstDash val="solid"/>
+          </a:ln>
+        </p:spPr>
+      </p:sp>
+      <p:sp>
+        <p:nvSpPr>
+          <p:cNvPr id="9" name="Shape 4"/>
+          <p:cNvSpPr/>
+          <p:nvPr/>
+        </p:nvSpPr>
+        <p:spPr>
+          <a:xfrm flipV="1">
+            <a:off x="1813439" y="5679252"/>
+            <a:ext cx="310518" cy="26253"/>
+          </a:xfrm>
+          <a:prstGeom prst="line">
+            <a:avLst/>
+          </a:prstGeom>
+          <a:noFill/>
+          <a:ln w="50800">
+            <a:solidFill>
+              <a:srgbClr val="0F7B4C"/>
+            </a:solidFill>
+            <a:prstDash val="solid"/>
+          </a:ln>
+        </p:spPr>
+      </p:sp>
+      <p:sp>
+        <p:nvSpPr>
+          <p:cNvPr id="10" name="Shape 5"/>
+          <p:cNvSpPr/>
+          <p:nvPr/>
+        </p:nvSpPr>
+        <p:spPr>
+          <a:xfrm flipV="1">
+            <a:off x="2123957" y="5639594"/>
+            <a:ext cx="266421" cy="39658"/>
+          </a:xfrm>
+          <a:prstGeom prst="line">
+            <a:avLst/>
+          </a:prstGeom>
+          <a:noFill/>
+          <a:ln w="50800">
+            <a:solidFill>
+              <a:srgbClr val="0F7B4C"/>
+            </a:solidFill>
+            <a:prstDash val="solid"/>
+          </a:ln>
+        </p:spPr>
+      </p:sp>
+      <p:sp>
+        <p:nvSpPr>
+          <p:cNvPr id="11" name="Shape 6"/>
+          <p:cNvSpPr/>
+          <p:nvPr/>
+        </p:nvSpPr>
+        <p:spPr>
+          <a:xfrm flipV="1">
+            <a:off x="2390378" y="5589881"/>
+            <a:ext cx="233348" cy="49712"/>
+          </a:xfrm>
+          <a:prstGeom prst="line">
+            <a:avLst/>
+          </a:prstGeom>
+          <a:noFill/>
+          <a:ln w="50800">
+            <a:solidFill>
+              <a:srgbClr val="0F7B4C"/>
+            </a:solidFill>
+            <a:prstDash val="solid"/>
+          </a:ln>
+        </p:spPr>
+      </p:sp>
+      <p:sp>
+        <p:nvSpPr>
+          <p:cNvPr id="12" name="Shape 7"/>
+          <p:cNvSpPr/>
+          <p:nvPr/>
+        </p:nvSpPr>
+        <p:spPr>
+          <a:xfrm flipV="1">
+            <a:off x="2623726" y="5533466"/>
+            <a:ext cx="211299" cy="56415"/>
+          </a:xfrm>
+          <a:prstGeom prst="line">
+            <a:avLst/>
+          </a:prstGeom>
+          <a:noFill/>
+          <a:ln w="50800">
+            <a:solidFill>
+              <a:srgbClr val="0F7B4C"/>
+            </a:solidFill>
+            <a:prstDash val="solid"/>
+          </a:ln>
+        </p:spPr>
+      </p:sp>
+      <p:sp>
+        <p:nvSpPr>
+          <p:cNvPr id="13" name="Shape 8"/>
+          <p:cNvSpPr/>
+          <p:nvPr/>
+        </p:nvSpPr>
+        <p:spPr>
+          <a:xfrm flipV="1">
+            <a:off x="2835025" y="5473700"/>
+            <a:ext cx="200275" cy="59766"/>
+          </a:xfrm>
+          <a:prstGeom prst="line">
+            <a:avLst/>
+          </a:prstGeom>
+          <a:noFill/>
+          <a:ln w="50800">
+            <a:solidFill>
+              <a:srgbClr val="0F7B4C"/>
+            </a:solidFill>
+            <a:prstDash val="solid"/>
+          </a:ln>
+        </p:spPr>
+      </p:sp>
+      <p:sp>
+        <p:nvSpPr>
+          <p:cNvPr id="14" name="Shape 9"/>
+          <p:cNvSpPr/>
+          <p:nvPr/>
+        </p:nvSpPr>
+        <p:spPr>
+          <a:xfrm flipV="1">
+            <a:off x="3035300" y="5413934"/>
+            <a:ext cx="200275" cy="59766"/>
+          </a:xfrm>
+          <a:prstGeom prst="line">
+            <a:avLst/>
+          </a:prstGeom>
+          <a:noFill/>
+          <a:ln w="50800">
+            <a:solidFill>
+              <a:srgbClr val="0F7B4C"/>
+            </a:solidFill>
+            <a:prstDash val="solid"/>
+          </a:ln>
+        </p:spPr>
+      </p:sp>
+      <p:sp>
+        <p:nvSpPr>
+          <p:cNvPr id="15" name="Shape 10"/>
+          <p:cNvSpPr/>
+          <p:nvPr/>
+        </p:nvSpPr>
+        <p:spPr>
+          <a:xfrm flipV="1">
+            <a:off x="3235575" y="5357519"/>
+            <a:ext cx="211299" cy="56415"/>
+          </a:xfrm>
+          <a:prstGeom prst="line">
+            <a:avLst/>
+          </a:prstGeom>
+          <a:noFill/>
+          <a:ln w="50800">
+            <a:solidFill>
+              <a:srgbClr val="0F7B4C"/>
+            </a:solidFill>
+            <a:prstDash val="solid"/>
+          </a:ln>
+        </p:spPr>
+      </p:sp>
+      <p:sp>
+        <p:nvSpPr>
+          <p:cNvPr id="16" name="Shape 11"/>
+          <p:cNvSpPr/>
+          <p:nvPr/>
+        </p:nvSpPr>
+        <p:spPr>
+          <a:xfrm flipV="1">
+            <a:off x="3446874" y="5307806"/>
+            <a:ext cx="233348" cy="49712"/>
+          </a:xfrm>
+          <a:prstGeom prst="line">
+            <a:avLst/>
+          </a:prstGeom>
+          <a:noFill/>
+          <a:ln w="50800">
+            <a:solidFill>
+              <a:srgbClr val="0F7B4C"/>
+            </a:solidFill>
+            <a:prstDash val="solid"/>
+          </a:ln>
+        </p:spPr>
+      </p:sp>
+      <p:sp>
+        <p:nvSpPr>
+          <p:cNvPr id="17" name="Shape 12"/>
+          <p:cNvSpPr/>
+          <p:nvPr/>
+        </p:nvSpPr>
+        <p:spPr>
+          <a:xfrm flipV="1">
+            <a:off x="3680222" y="5268148"/>
+            <a:ext cx="266421" cy="39658"/>
+          </a:xfrm>
+          <a:prstGeom prst="line">
+            <a:avLst/>
+          </a:prstGeom>
+          <a:noFill/>
+          <a:ln w="50800">
+            <a:solidFill>
+              <a:srgbClr val="0F7B4C"/>
+            </a:solidFill>
+            <a:prstDash val="solid"/>
+          </a:ln>
+        </p:spPr>
+      </p:sp>
+      <p:sp>
+        <p:nvSpPr>
+          <p:cNvPr id="18" name="Shape 13"/>
+          <p:cNvSpPr/>
+          <p:nvPr/>
+        </p:nvSpPr>
+        <p:spPr>
+          <a:xfrm flipV="1">
+            <a:off x="3946643" y="5241896"/>
+            <a:ext cx="310518" cy="26253"/>
+          </a:xfrm>
+          <a:prstGeom prst="line">
+            <a:avLst/>
+          </a:prstGeom>
+          <a:noFill/>
+          <a:ln w="50800">
+            <a:solidFill>
+              <a:srgbClr val="0F7B4C"/>
+            </a:solidFill>
+            <a:prstDash val="solid"/>
+          </a:ln>
+        </p:spPr>
+      </p:sp>
+      <p:sp>
+        <p:nvSpPr>
+          <p:cNvPr id="19" name="Shape 14"/>
+          <p:cNvSpPr/>
+          <p:nvPr/>
+        </p:nvSpPr>
+        <p:spPr>
+          <a:xfrm flipV="1">
+            <a:off x="4257161" y="5232400"/>
+            <a:ext cx="365639" cy="9496"/>
+          </a:xfrm>
+          <a:prstGeom prst="line">
+            <a:avLst/>
+          </a:prstGeom>
+          <a:noFill/>
+          <a:ln w="50800">
+            <a:solidFill>
+              <a:srgbClr val="0F7B4C"/>
+            </a:solidFill>
+            <a:prstDash val="solid"/>
+          </a:ln>
+        </p:spPr>
+      </p:sp>
+      <p:sp>
+        <p:nvSpPr>
+          <p:cNvPr id="20" name="Shape 15"/>
+          <p:cNvSpPr/>
+          <p:nvPr/>
+        </p:nvSpPr>
+        <p:spPr>
+          <a:xfrm flipV="1">
+            <a:off x="4622800" y="5218157"/>
+            <a:ext cx="365639" cy="14243"/>
+          </a:xfrm>
+          <a:prstGeom prst="line">
+            <a:avLst/>
+          </a:prstGeom>
+          <a:noFill/>
+          <a:ln w="50800">
+            <a:solidFill>
+              <a:srgbClr val="0F7B4C"/>
+            </a:solidFill>
+            <a:prstDash val="solid"/>
+          </a:ln>
+        </p:spPr>
+      </p:sp>
+      <p:sp>
+        <p:nvSpPr>
+          <p:cNvPr id="21" name="Shape 16"/>
+          <p:cNvSpPr/>
+          <p:nvPr/>
+        </p:nvSpPr>
+        <p:spPr>
+          <a:xfrm flipV="1">
+            <a:off x="4988439" y="5178778"/>
+            <a:ext cx="310518" cy="39379"/>
+          </a:xfrm>
+          <a:prstGeom prst="line">
+            <a:avLst/>
+          </a:prstGeom>
+          <a:noFill/>
+          <a:ln w="50800">
+            <a:solidFill>
+              <a:srgbClr val="0F7B4C"/>
+            </a:solidFill>
+            <a:prstDash val="solid"/>
+          </a:ln>
+        </p:spPr>
+      </p:sp>
+      <p:sp>
+        <p:nvSpPr>
+          <p:cNvPr id="22" name="Shape 17"/>
+          <p:cNvSpPr/>
+          <p:nvPr/>
+        </p:nvSpPr>
+        <p:spPr>
+          <a:xfrm flipV="1">
+            <a:off x="5298957" y="5119291"/>
+            <a:ext cx="266421" cy="59487"/>
+          </a:xfrm>
+          <a:prstGeom prst="line">
+            <a:avLst/>
+          </a:prstGeom>
+          <a:noFill/>
+          <a:ln w="50800">
+            <a:solidFill>
+              <a:srgbClr val="0F7B4C"/>
+            </a:solidFill>
+            <a:prstDash val="solid"/>
+          </a:ln>
+        </p:spPr>
+      </p:sp>
+      <p:sp>
+        <p:nvSpPr>
+          <p:cNvPr id="23" name="Shape 18"/>
+          <p:cNvSpPr/>
+          <p:nvPr/>
+        </p:nvSpPr>
+        <p:spPr>
+          <a:xfrm flipV="1">
+            <a:off x="5565378" y="5044722"/>
+            <a:ext cx="233348" cy="74568"/>
+          </a:xfrm>
+          <a:prstGeom prst="line">
+            <a:avLst/>
+          </a:prstGeom>
+          <a:noFill/>
+          <a:ln w="50800">
+            <a:solidFill>
+              <a:srgbClr val="0F7B4C"/>
+            </a:solidFill>
+            <a:prstDash val="solid"/>
+          </a:ln>
+        </p:spPr>
+      </p:sp>
+      <p:sp>
+        <p:nvSpPr>
+          <p:cNvPr id="24" name="Shape 19"/>
+          <p:cNvSpPr/>
+          <p:nvPr/>
+        </p:nvSpPr>
+        <p:spPr>
+          <a:xfrm flipV="1">
+            <a:off x="5798726" y="4960100"/>
+            <a:ext cx="211299" cy="84623"/>
+          </a:xfrm>
+          <a:prstGeom prst="line">
+            <a:avLst/>
+          </a:prstGeom>
+          <a:noFill/>
+          <a:ln w="50800">
+            <a:solidFill>
+              <a:srgbClr val="0F7B4C"/>
+            </a:solidFill>
+            <a:prstDash val="solid"/>
+          </a:ln>
+        </p:spPr>
+      </p:sp>
+      <p:sp>
+        <p:nvSpPr>
+          <p:cNvPr id="25" name="Shape 20"/>
+          <p:cNvSpPr/>
+          <p:nvPr/>
+        </p:nvSpPr>
+        <p:spPr>
+          <a:xfrm flipV="1">
+            <a:off x="6010025" y="4870450"/>
+            <a:ext cx="200275" cy="89650"/>
+          </a:xfrm>
+          <a:prstGeom prst="line">
+            <a:avLst/>
+          </a:prstGeom>
+          <a:noFill/>
+          <a:ln w="50800">
+            <a:solidFill>
+              <a:srgbClr val="0F7B4C"/>
+            </a:solidFill>
+            <a:prstDash val="solid"/>
+          </a:ln>
+        </p:spPr>
+      </p:sp>
+      <p:sp>
+        <p:nvSpPr>
+          <p:cNvPr id="26" name="Shape 21"/>
+          <p:cNvSpPr/>
+          <p:nvPr/>
+        </p:nvSpPr>
+        <p:spPr>
+          <a:xfrm flipV="1">
+            <a:off x="6210300" y="4780800"/>
+            <a:ext cx="200275" cy="89650"/>
+          </a:xfrm>
+          <a:prstGeom prst="line">
+            <a:avLst/>
+          </a:prstGeom>
+          <a:noFill/>
+          <a:ln w="50800">
+            <a:solidFill>
+              <a:srgbClr val="0F7B4C"/>
+            </a:solidFill>
+            <a:prstDash val="solid"/>
+          </a:ln>
+        </p:spPr>
+      </p:sp>
+      <p:sp>
+        <p:nvSpPr>
+          <p:cNvPr id="27" name="Shape 22"/>
+          <p:cNvSpPr/>
+          <p:nvPr/>
+        </p:nvSpPr>
+        <p:spPr>
+          <a:xfrm flipV="1">
+            <a:off x="6410575" y="4696178"/>
+            <a:ext cx="211299" cy="84623"/>
+          </a:xfrm>
+          <a:prstGeom prst="line">
+            <a:avLst/>
+          </a:prstGeom>
+          <a:noFill/>
+          <a:ln w="50800">
+            <a:solidFill>
+              <a:srgbClr val="0F7B4C"/>
+            </a:solidFill>
+            <a:prstDash val="solid"/>
+          </a:ln>
+        </p:spPr>
+      </p:sp>
+      <p:sp>
+        <p:nvSpPr>
+          <p:cNvPr id="28" name="Shape 23"/>
+          <p:cNvSpPr/>
+          <p:nvPr/>
+        </p:nvSpPr>
+        <p:spPr>
+          <a:xfrm flipV="1">
+            <a:off x="6621874" y="4621609"/>
+            <a:ext cx="233348" cy="74568"/>
+          </a:xfrm>
+          <a:prstGeom prst="line">
+            <a:avLst/>
+          </a:prstGeom>
+          <a:noFill/>
+          <a:ln w="50800">
+            <a:solidFill>
+              <a:srgbClr val="0F7B4C"/>
+            </a:solidFill>
+            <a:prstDash val="solid"/>
+          </a:ln>
+        </p:spPr>
+      </p:sp>
+      <p:sp>
+        <p:nvSpPr>
+          <p:cNvPr id="29" name="Shape 24"/>
+          <p:cNvSpPr/>
+          <p:nvPr/>
+        </p:nvSpPr>
+        <p:spPr>
+          <a:xfrm flipV="1">
+            <a:off x="6855222" y="4562122"/>
+            <a:ext cx="266421" cy="59487"/>
+          </a:xfrm>
+          <a:prstGeom prst="line">
+            <a:avLst/>
+          </a:prstGeom>
+          <a:noFill/>
+          <a:ln w="50800">
+            <a:solidFill>
+              <a:srgbClr val="0F7B4C"/>
+            </a:solidFill>
+            <a:prstDash val="solid"/>
+          </a:ln>
+        </p:spPr>
+      </p:sp>
+      <p:sp>
+        <p:nvSpPr>
+          <p:cNvPr id="30" name="Shape 25"/>
+          <p:cNvSpPr/>
+          <p:nvPr/>
+        </p:nvSpPr>
+        <p:spPr>
+          <a:xfrm flipV="1">
+            <a:off x="7121643" y="4522743"/>
+            <a:ext cx="310518" cy="39379"/>
+          </a:xfrm>
+          <a:prstGeom prst="line">
+            <a:avLst/>
+          </a:prstGeom>
+          <a:noFill/>
+          <a:ln w="50800">
+            <a:solidFill>
+              <a:srgbClr val="0F7B4C"/>
+            </a:solidFill>
+            <a:prstDash val="solid"/>
+          </a:ln>
+        </p:spPr>
+      </p:sp>
+      <p:sp>
+        <p:nvSpPr>
+          <p:cNvPr id="31" name="Shape 26"/>
+          <p:cNvSpPr/>
+          <p:nvPr/>
+        </p:nvSpPr>
+        <p:spPr>
+          <a:xfrm flipV="1">
+            <a:off x="7432161" y="4508500"/>
+            <a:ext cx="365639" cy="14243"/>
+          </a:xfrm>
+          <a:prstGeom prst="line">
+            <a:avLst/>
+          </a:prstGeom>
+          <a:noFill/>
+          <a:ln w="50800">
+            <a:solidFill>
+              <a:srgbClr val="0F7B4C"/>
+            </a:solidFill>
+            <a:prstDash val="solid"/>
+          </a:ln>
+        </p:spPr>
+      </p:sp>
+      <p:sp>
+        <p:nvSpPr>
+          <p:cNvPr id="32" name="Shape 27"/>
+          <p:cNvSpPr/>
+          <p:nvPr/>
+        </p:nvSpPr>
+        <p:spPr>
+          <a:xfrm flipV="1">
+            <a:off x="7797800" y="4484761"/>
+            <a:ext cx="365639" cy="23739"/>
+          </a:xfrm>
+          <a:prstGeom prst="line">
+            <a:avLst/>
+          </a:prstGeom>
+          <a:noFill/>
+          <a:ln w="50800">
+            <a:solidFill>
+              <a:srgbClr val="0F7B4C"/>
+            </a:solidFill>
+            <a:prstDash val="solid"/>
+          </a:ln>
+        </p:spPr>
+      </p:sp>
+      <p:sp>
+        <p:nvSpPr>
+          <p:cNvPr id="33" name="Shape 28"/>
+          <p:cNvSpPr/>
+          <p:nvPr/>
+        </p:nvSpPr>
+        <p:spPr>
+          <a:xfrm flipV="1">
+            <a:off x="8163439" y="4419130"/>
+            <a:ext cx="310518" cy="65631"/>
+          </a:xfrm>
+          <a:prstGeom prst="line">
+            <a:avLst/>
+          </a:prstGeom>
+          <a:noFill/>
+          <a:ln w="50800">
+            <a:solidFill>
+              <a:srgbClr val="0F7B4C"/>
+            </a:solidFill>
+            <a:prstDash val="solid"/>
+          </a:ln>
+        </p:spPr>
+      </p:sp>
+      <p:sp>
+        <p:nvSpPr>
+          <p:cNvPr id="34" name="Shape 29"/>
+          <p:cNvSpPr/>
+          <p:nvPr/>
+        </p:nvSpPr>
+        <p:spPr>
+          <a:xfrm flipV="1">
+            <a:off x="8473957" y="4319984"/>
+            <a:ext cx="266421" cy="99145"/>
+          </a:xfrm>
+          <a:prstGeom prst="line">
+            <a:avLst/>
+          </a:prstGeom>
+          <a:noFill/>
+          <a:ln w="50800">
+            <a:solidFill>
+              <a:srgbClr val="0F7B4C"/>
+            </a:solidFill>
+            <a:prstDash val="solid"/>
+          </a:ln>
+        </p:spPr>
+      </p:sp>
+      <p:sp>
+        <p:nvSpPr>
+          <p:cNvPr id="35" name="Shape 30"/>
+          <p:cNvSpPr/>
+          <p:nvPr/>
+        </p:nvSpPr>
+        <p:spPr>
+          <a:xfrm flipV="1">
+            <a:off x="8740378" y="4195704"/>
+            <a:ext cx="233348" cy="124281"/>
+          </a:xfrm>
+          <a:prstGeom prst="line">
+            <a:avLst/>
+          </a:prstGeom>
+          <a:noFill/>
+          <a:ln w="50800">
+            <a:solidFill>
+              <a:srgbClr val="0F7B4C"/>
+            </a:solidFill>
+            <a:prstDash val="solid"/>
+          </a:ln>
+        </p:spPr>
+      </p:sp>
+      <p:sp>
+        <p:nvSpPr>
+          <p:cNvPr id="36" name="Shape 31"/>
+          <p:cNvSpPr/>
+          <p:nvPr/>
+        </p:nvSpPr>
+        <p:spPr>
+          <a:xfrm flipV="1">
+            <a:off x="8973726" y="4054666"/>
+            <a:ext cx="211299" cy="141038"/>
+          </a:xfrm>
+          <a:prstGeom prst="line">
+            <a:avLst/>
+          </a:prstGeom>
+          <a:noFill/>
+          <a:ln w="50800">
+            <a:solidFill>
+              <a:srgbClr val="0F7B4C"/>
+            </a:solidFill>
+            <a:prstDash val="solid"/>
+          </a:ln>
+        </p:spPr>
+      </p:sp>
+      <p:sp>
+        <p:nvSpPr>
+          <p:cNvPr id="37" name="Shape 32"/>
+          <p:cNvSpPr/>
+          <p:nvPr/>
+        </p:nvSpPr>
+        <p:spPr>
+          <a:xfrm flipV="1">
+            <a:off x="9185025" y="3905250"/>
+            <a:ext cx="200275" cy="149416"/>
+          </a:xfrm>
+          <a:prstGeom prst="line">
+            <a:avLst/>
+          </a:prstGeom>
+          <a:noFill/>
+          <a:ln w="50800">
+            <a:solidFill>
+              <a:srgbClr val="0F7B4C"/>
+            </a:solidFill>
+            <a:prstDash val="solid"/>
+          </a:ln>
+        </p:spPr>
+      </p:sp>
+      <p:sp>
+        <p:nvSpPr>
+          <p:cNvPr id="38" name="Shape 33"/>
+          <p:cNvSpPr/>
+          <p:nvPr/>
+        </p:nvSpPr>
+        <p:spPr>
+          <a:xfrm flipV="1">
+            <a:off x="9385300" y="3755834"/>
+            <a:ext cx="200275" cy="149416"/>
+          </a:xfrm>
+          <a:prstGeom prst="line">
+            <a:avLst/>
+          </a:prstGeom>
+          <a:noFill/>
+          <a:ln w="50800">
+            <a:solidFill>
+              <a:srgbClr val="0F7B4C"/>
+            </a:solidFill>
+            <a:prstDash val="solid"/>
+          </a:ln>
+        </p:spPr>
+      </p:sp>
+      <p:sp>
+        <p:nvSpPr>
+          <p:cNvPr id="39" name="Shape 34"/>
+          <p:cNvSpPr/>
+          <p:nvPr/>
+        </p:nvSpPr>
+        <p:spPr>
+          <a:xfrm flipV="1">
+            <a:off x="9585575" y="3614796"/>
+            <a:ext cx="211299" cy="141038"/>
+          </a:xfrm>
+          <a:prstGeom prst="line">
+            <a:avLst/>
+          </a:prstGeom>
+          <a:noFill/>
+          <a:ln w="50800">
+            <a:solidFill>
+              <a:srgbClr val="0F7B4C"/>
+            </a:solidFill>
+            <a:prstDash val="solid"/>
+          </a:ln>
+        </p:spPr>
+      </p:sp>
+      <p:sp>
+        <p:nvSpPr>
+          <p:cNvPr id="40" name="Shape 35"/>
+          <p:cNvSpPr/>
+          <p:nvPr/>
+        </p:nvSpPr>
+        <p:spPr>
+          <a:xfrm flipV="1">
+            <a:off x="9796874" y="3490516"/>
+            <a:ext cx="233348" cy="124281"/>
+          </a:xfrm>
+          <a:prstGeom prst="line">
+            <a:avLst/>
+          </a:prstGeom>
+          <a:noFill/>
+          <a:ln w="50800">
+            <a:solidFill>
+              <a:srgbClr val="0F7B4C"/>
+            </a:solidFill>
+            <a:prstDash val="solid"/>
+          </a:ln>
+        </p:spPr>
+      </p:sp>
+      <p:sp>
+        <p:nvSpPr>
+          <p:cNvPr id="41" name="Shape 36"/>
+          <p:cNvSpPr/>
+          <p:nvPr/>
+        </p:nvSpPr>
+        <p:spPr>
+          <a:xfrm flipV="1">
+            <a:off x="10030222" y="3391370"/>
+            <a:ext cx="266421" cy="99145"/>
+          </a:xfrm>
+          <a:prstGeom prst="line">
+            <a:avLst/>
+          </a:prstGeom>
+          <a:noFill/>
+          <a:ln w="50800">
+            <a:solidFill>
+              <a:srgbClr val="0F7B4C"/>
+            </a:solidFill>
+            <a:prstDash val="solid"/>
+          </a:ln>
+        </p:spPr>
+      </p:sp>
+      <p:sp>
+        <p:nvSpPr>
+          <p:cNvPr id="42" name="Shape 37"/>
+          <p:cNvSpPr/>
+          <p:nvPr/>
+        </p:nvSpPr>
+        <p:spPr>
+          <a:xfrm flipV="1">
+            <a:off x="10296643" y="3325739"/>
+            <a:ext cx="310518" cy="65631"/>
+          </a:xfrm>
+          <a:prstGeom prst="line">
+            <a:avLst/>
+          </a:prstGeom>
+          <a:noFill/>
+          <a:ln w="50800">
+            <a:solidFill>
+              <a:srgbClr val="0F7B4C"/>
+            </a:solidFill>
+            <a:prstDash val="solid"/>
+          </a:ln>
+        </p:spPr>
+      </p:sp>
+      <p:sp>
+        <p:nvSpPr>
+          <p:cNvPr id="43" name="Shape 38"/>
+          <p:cNvSpPr/>
+          <p:nvPr/>
+        </p:nvSpPr>
+        <p:spPr>
+          <a:xfrm flipV="1">
+            <a:off x="10607161" y="3302000"/>
+            <a:ext cx="365639" cy="23739"/>
+          </a:xfrm>
+          <a:prstGeom prst="line">
+            <a:avLst/>
+          </a:prstGeom>
+          <a:noFill/>
+          <a:ln w="50800">
+            <a:solidFill>
+              <a:srgbClr val="0F7B4C"/>
+            </a:solidFill>
+            <a:prstDash val="solid"/>
+          </a:ln>
+        </p:spPr>
+      </p:sp>
+      <p:sp>
+        <p:nvSpPr>
+          <p:cNvPr id="44" name="Shape 39"/>
+          <p:cNvSpPr/>
+          <p:nvPr/>
+        </p:nvSpPr>
+        <p:spPr>
+          <a:xfrm>
+            <a:off x="1193800" y="5715000"/>
+            <a:ext cx="10033000" cy="19050"/>
+          </a:xfrm>
+          <a:prstGeom prst="rect">
+            <a:avLst/>
+          </a:prstGeom>
+          <a:solidFill>
+            <a:srgbClr val="14213D"/>
+          </a:solidFill>
+          <a:ln w="12700">
+            <a:solidFill>
+              <a:srgbClr val="14213D"/>
+            </a:solidFill>
+            <a:prstDash val="solid"/>
+          </a:ln>
+        </p:spPr>
+      </p:sp>
+      <p:sp>
+        <p:nvSpPr>
+          <p:cNvPr id="45" name="Shape 40"/>
+          <p:cNvSpPr/>
+          <p:nvPr/>
+        </p:nvSpPr>
+        <p:spPr>
+          <a:xfrm>
+            <a:off x="1358900" y="5626100"/>
+            <a:ext cx="177800" cy="177800"/>
+          </a:xfrm>
+          <a:prstGeom prst="ellipse">
+            <a:avLst/>
+          </a:prstGeom>
+          <a:solidFill>
+            <a:srgbClr val="FFF7DC"/>
+          </a:solidFill>
+          <a:ln w="38100">
+            <a:solidFill>
+              <a:srgbClr val="14213D"/>
+            </a:solidFill>
+            <a:prstDash val="solid"/>
+          </a:ln>
+        </p:spPr>
+      </p:sp>
+      <p:sp>
+        <p:nvSpPr>
+          <p:cNvPr id="46" name="Shape 41"/>
+          <p:cNvSpPr/>
+          <p:nvPr/>
+        </p:nvSpPr>
+        <p:spPr>
+          <a:xfrm>
+            <a:off x="4533900" y="5143500"/>
+            <a:ext cx="177800" cy="177800"/>
+          </a:xfrm>
+          <a:prstGeom prst="ellipse">
+            <a:avLst/>
+          </a:prstGeom>
+          <a:solidFill>
+            <a:srgbClr val="E8A800"/>
+          </a:solidFill>
+          <a:ln w="38100">
+            <a:solidFill>
+              <a:srgbClr val="14213D"/>
+            </a:solidFill>
+            <a:prstDash val="solid"/>
+          </a:ln>
+        </p:spPr>
+      </p:sp>
+      <p:sp>
+        <p:nvSpPr>
+          <p:cNvPr id="47" name="Shape 42"/>
+          <p:cNvSpPr/>
+          <p:nvPr/>
+        </p:nvSpPr>
+        <p:spPr>
+          <a:xfrm>
+            <a:off x="7708900" y="4419600"/>
+            <a:ext cx="177800" cy="177800"/>
+          </a:xfrm>
+          <a:prstGeom prst="ellipse">
+            <a:avLst/>
+          </a:prstGeom>
+          <a:solidFill>
+            <a:srgbClr val="E8A800"/>
+          </a:solidFill>
+          <a:ln w="38100">
+            <a:solidFill>
+              <a:srgbClr val="14213D"/>
+            </a:solidFill>
+            <a:prstDash val="solid"/>
+          </a:ln>
+        </p:spPr>
+      </p:sp>
+      <p:sp>
+        <p:nvSpPr>
+          <p:cNvPr id="48" name="Shape 43"/>
+          <p:cNvSpPr/>
+          <p:nvPr/>
+        </p:nvSpPr>
+        <p:spPr>
+          <a:xfrm>
+            <a:off x="10871200" y="3200400"/>
+            <a:ext cx="203200" cy="203200"/>
+          </a:xfrm>
+          <a:prstGeom prst="ellipse">
+            <a:avLst/>
+          </a:prstGeom>
+          <a:solidFill>
+            <a:srgbClr val="0F7B4C"/>
+          </a:solidFill>
+          <a:ln w="38100">
+            <a:solidFill>
+              <a:srgbClr val="14213D"/>
+            </a:solidFill>
+            <a:prstDash val="solid"/>
+          </a:ln>
+        </p:spPr>
+      </p:sp>
+      <p:sp>
+        <p:nvSpPr>
+          <p:cNvPr id="49" name="Text 44"/>
+          <p:cNvSpPr txBox="1"/>
+          <p:nvPr/>
+        </p:nvSpPr>
+        <p:spPr>
+          <a:xfrm>
+            <a:off x="812800" y="4953000"/>
+            <a:ext cx="1397000" cy="381000"/>
+          </a:xfrm>
+          <a:prstGeom prst="rect">
+            <a:avLst/>
+          </a:prstGeom>
+          <a:noFill/>
+          <a:ln/>
+        </p:spPr>
+        <p:txBody>
+          <a:bodyPr wrap="square" lIns="0" tIns="0" rIns="0" bIns="0" rtlCol="0" anchor="t"/>
+          <a:lstStyle/>
+          <a:p>
+            <a:pPr indent="0" marL="0">
+              <a:lnSpc>
+                <a:spcPct val="105000"/>
+              </a:lnSpc>
+              <a:buNone/>
+            </a:pPr>
+            <a:r>
+              <a:rPr lang="en-US" sz="2800" dirty="0">
+                <a:solidFill>
+                  <a:srgbClr val="14213D"/>
+                </a:solidFill>
+                <a:latin typeface="Cambria" pitchFamily="34" charset="0"/>
+                <a:ea typeface="Cambria" pitchFamily="34" charset="-122"/>
+                <a:cs typeface="Cambria" pitchFamily="34" charset="-120"/>
+              </a:rPr>
+              <a:t>100</a:t>
+            </a:r>
+            <a:endParaRPr lang="en-US" sz="2800" dirty="0"/>
+          </a:p>
+        </p:txBody>
+      </p:sp>
+      <p:sp>
+        <p:nvSpPr>
+          <p:cNvPr id="50" name="Text 45"/>
+          <p:cNvSpPr txBox="1"/>
+          <p:nvPr/>
+        </p:nvSpPr>
+        <p:spPr>
+          <a:xfrm>
+            <a:off x="812800" y="5346700"/>
+            <a:ext cx="1651000" cy="215900"/>
+          </a:xfrm>
+          <a:prstGeom prst="rect">
+            <a:avLst/>
+          </a:prstGeom>
+          <a:noFill/>
+          <a:ln/>
+        </p:spPr>
+        <p:txBody>
+          <a:bodyPr wrap="square" lIns="0" tIns="0" rIns="0" bIns="0" rtlCol="0" anchor="t"/>
+          <a:lstStyle/>
+          <a:p>
+            <a:pPr indent="0" marL="0">
               <a:buNone/>
             </a:pPr>
             <a:r>
@@ -4092,7 +4074,7 @@
                 <a:ea typeface="Calibri" pitchFamily="34" charset="-122"/>
                 <a:cs typeface="Calibri" pitchFamily="34" charset="-120"/>
               </a:rPr>
-              <a:t>60 colleges · ₹1.45 Cr</a:t>
+              <a:t>students · IEM pilot</a:t>
             </a:r>
             <a:endParaRPr lang="en-US" sz="1200" dirty="0"/>
           </a:p>
@@ -4100,14 +4082,137 @@
       </p:sp>
       <p:sp>
         <p:nvSpPr>
-          <p:cNvPr id="10" name="Text 4"/>
-          <p:cNvSpPr txBox="1"/>
-          <p:nvPr/>
-        </p:nvSpPr>
-        <p:spPr>
-          <a:xfrm>
-            <a:off x="6223000" y="3556000"/>
-            <a:ext cx="2032000" cy="215900"/>
+          <p:cNvPr id="51" name="Text 46"/>
+          <p:cNvSpPr txBox="1"/>
+          <p:nvPr/>
+        </p:nvSpPr>
+        <p:spPr>
+          <a:xfrm>
+            <a:off x="3797300" y="4318000"/>
+            <a:ext cx="1905000" cy="381000"/>
+          </a:xfrm>
+          <a:prstGeom prst="rect">
+            <a:avLst/>
+          </a:prstGeom>
+          <a:noFill/>
+          <a:ln/>
+        </p:spPr>
+        <p:txBody>
+          <a:bodyPr wrap="square" lIns="0" tIns="0" rIns="0" bIns="0" rtlCol="0" anchor="t"/>
+          <a:lstStyle/>
+          <a:p>
+            <a:pPr indent="0" marL="0">
+              <a:lnSpc>
+                <a:spcPct val="105000"/>
+              </a:lnSpc>
+              <a:buNone/>
+            </a:pPr>
+            <a:r>
+              <a:rPr lang="en-US" sz="2800" dirty="0">
+                <a:solidFill>
+                  <a:srgbClr val="14213D"/>
+                </a:solidFill>
+                <a:latin typeface="Cambria" pitchFamily="34" charset="0"/>
+                <a:ea typeface="Cambria" pitchFamily="34" charset="-122"/>
+                <a:cs typeface="Cambria" pitchFamily="34" charset="-120"/>
+              </a:rPr>
+              <a:t>1,00,000</a:t>
+            </a:r>
+            <a:endParaRPr lang="en-US" sz="2800" dirty="0"/>
+          </a:p>
+        </p:txBody>
+      </p:sp>
+      <p:sp>
+        <p:nvSpPr>
+          <p:cNvPr id="52" name="Text 47"/>
+          <p:cNvSpPr txBox="1"/>
+          <p:nvPr/>
+        </p:nvSpPr>
+        <p:spPr>
+          <a:xfrm>
+            <a:off x="6908800" y="3594100"/>
+            <a:ext cx="1905000" cy="381000"/>
+          </a:xfrm>
+          <a:prstGeom prst="rect">
+            <a:avLst/>
+          </a:prstGeom>
+          <a:noFill/>
+          <a:ln/>
+        </p:spPr>
+        <p:txBody>
+          <a:bodyPr wrap="square" lIns="0" tIns="0" rIns="0" bIns="0" rtlCol="0" anchor="t"/>
+          <a:lstStyle/>
+          <a:p>
+            <a:pPr indent="0" marL="0">
+              <a:lnSpc>
+                <a:spcPct val="105000"/>
+              </a:lnSpc>
+              <a:buNone/>
+            </a:pPr>
+            <a:r>
+              <a:rPr lang="en-US" sz="2800" dirty="0">
+                <a:solidFill>
+                  <a:srgbClr val="14213D"/>
+                </a:solidFill>
+                <a:latin typeface="Cambria" pitchFamily="34" charset="0"/>
+                <a:ea typeface="Cambria" pitchFamily="34" charset="-122"/>
+                <a:cs typeface="Cambria" pitchFamily="34" charset="-120"/>
+              </a:rPr>
+              <a:t>2,50,000</a:t>
+            </a:r>
+            <a:endParaRPr lang="en-US" sz="2800" dirty="0"/>
+          </a:p>
+        </p:txBody>
+      </p:sp>
+      <p:sp>
+        <p:nvSpPr>
+          <p:cNvPr id="53" name="Text 48"/>
+          <p:cNvSpPr txBox="1"/>
+          <p:nvPr/>
+        </p:nvSpPr>
+        <p:spPr>
+          <a:xfrm>
+            <a:off x="9258300" y="2413000"/>
+            <a:ext cx="2095500" cy="444500"/>
+          </a:xfrm>
+          <a:prstGeom prst="rect">
+            <a:avLst/>
+          </a:prstGeom>
+          <a:noFill/>
+          <a:ln/>
+        </p:spPr>
+        <p:txBody>
+          <a:bodyPr wrap="square" lIns="0" tIns="0" rIns="0" bIns="0" rtlCol="0" anchor="t"/>
+          <a:lstStyle/>
+          <a:p>
+            <a:pPr algn="r" indent="0" marL="0">
+              <a:buNone/>
+            </a:pPr>
+            <a:r>
+              <a:rPr lang="en-US" sz="3200" dirty="0">
+                <a:solidFill>
+                  <a:srgbClr val="0F7B4C"/>
+                </a:solidFill>
+                <a:latin typeface="Cambria" pitchFamily="34" charset="0"/>
+                <a:ea typeface="Cambria" pitchFamily="34" charset="-122"/>
+                <a:cs typeface="Cambria" pitchFamily="34" charset="-120"/>
+              </a:rPr>
+              <a:t>5,00,000</a:t>
+            </a:r>
+            <a:endParaRPr lang="en-US" sz="3200" dirty="0"/>
+          </a:p>
+        </p:txBody>
+      </p:sp>
+      <p:sp>
+        <p:nvSpPr>
+          <p:cNvPr id="54" name="Text 49"/>
+          <p:cNvSpPr txBox="1"/>
+          <p:nvPr/>
+        </p:nvSpPr>
+        <p:spPr>
+          <a:xfrm>
+            <a:off x="812800" y="5842000"/>
+            <a:ext cx="1270000" cy="215900"/>
           </a:xfrm>
           <a:prstGeom prst="rect">
             <a:avLst/>
@@ -4123,53 +4228,248 @@
               <a:buNone/>
             </a:pPr>
             <a:r>
-              <a:rPr lang="en-US" sz="1200" b="1" dirty="0">
-                <a:solidFill>
-                  <a:srgbClr val="3B4760"/>
+              <a:rPr lang="en-US" sz="1300" b="1" spc="300" kern="0" dirty="0">
+                <a:solidFill>
+                  <a:srgbClr val="14213D"/>
                 </a:solidFill>
                 <a:latin typeface="Calibri" pitchFamily="34" charset="0"/>
                 <a:ea typeface="Calibri" pitchFamily="34" charset="-122"/>
                 <a:cs typeface="Calibri" pitchFamily="34" charset="-120"/>
               </a:rPr>
-              <a:t>150 colleges · ₹3.6 Cr</a:t>
-            </a:r>
-            <a:endParaRPr lang="en-US" sz="1200" dirty="0"/>
-          </a:p>
-        </p:txBody>
-      </p:sp>
-      <p:sp>
-        <p:nvSpPr>
-          <p:cNvPr id="11" name="Text 5"/>
-          <p:cNvSpPr txBox="1"/>
-          <p:nvPr/>
-        </p:nvSpPr>
-        <p:spPr>
-          <a:xfrm>
-            <a:off x="9144000" y="2540000"/>
-            <a:ext cx="2032000" cy="215900"/>
-          </a:xfrm>
-          <a:prstGeom prst="rect">
-            <a:avLst/>
-          </a:prstGeom>
-          <a:noFill/>
-          <a:ln/>
-        </p:spPr>
-        <p:txBody>
-          <a:bodyPr wrap="square" lIns="0" tIns="0" rIns="0" bIns="0" rtlCol="0" anchor="t"/>
-          <a:lstStyle/>
-          <a:p>
-            <a:pPr algn="r" indent="0" marL="0">
-              <a:buNone/>
-            </a:pPr>
-            <a:r>
-              <a:rPr lang="en-US" sz="1200" b="1" dirty="0">
-                <a:solidFill>
-                  <a:srgbClr val="0F7B4C"/>
+              <a:t>2026</a:t>
+            </a:r>
+            <a:endParaRPr lang="en-US" sz="1300" dirty="0"/>
+          </a:p>
+        </p:txBody>
+      </p:sp>
+      <p:sp>
+        <p:nvSpPr>
+          <p:cNvPr id="55" name="Text 50"/>
+          <p:cNvSpPr txBox="1"/>
+          <p:nvPr/>
+        </p:nvSpPr>
+        <p:spPr>
+          <a:xfrm>
+            <a:off x="3987800" y="5842000"/>
+            <a:ext cx="1270000" cy="215900"/>
+          </a:xfrm>
+          <a:prstGeom prst="rect">
+            <a:avLst/>
+          </a:prstGeom>
+          <a:noFill/>
+          <a:ln/>
+        </p:spPr>
+        <p:txBody>
+          <a:bodyPr wrap="square" lIns="0" tIns="0" rIns="0" bIns="0" rtlCol="0" anchor="t"/>
+          <a:lstStyle/>
+          <a:p>
+            <a:pPr algn="ctr" indent="0" marL="0">
+              <a:buNone/>
+            </a:pPr>
+            <a:r>
+              <a:rPr lang="en-US" sz="1300" b="1" spc="300" kern="0" dirty="0">
+                <a:solidFill>
+                  <a:srgbClr val="14213D"/>
                 </a:solidFill>
                 <a:latin typeface="Calibri" pitchFamily="34" charset="0"/>
                 <a:ea typeface="Calibri" pitchFamily="34" charset="-122"/>
                 <a:cs typeface="Calibri" pitchFamily="34" charset="-120"/>
               </a:rPr>
+              <a:t>YEAR 1</a:t>
+            </a:r>
+            <a:endParaRPr lang="en-US" sz="1300" dirty="0"/>
+          </a:p>
+        </p:txBody>
+      </p:sp>
+      <p:sp>
+        <p:nvSpPr>
+          <p:cNvPr id="56" name="Text 51"/>
+          <p:cNvSpPr txBox="1"/>
+          <p:nvPr/>
+        </p:nvSpPr>
+        <p:spPr>
+          <a:xfrm>
+            <a:off x="7162800" y="5842000"/>
+            <a:ext cx="1270000" cy="215900"/>
+          </a:xfrm>
+          <a:prstGeom prst="rect">
+            <a:avLst/>
+          </a:prstGeom>
+          <a:noFill/>
+          <a:ln/>
+        </p:spPr>
+        <p:txBody>
+          <a:bodyPr wrap="square" lIns="0" tIns="0" rIns="0" bIns="0" rtlCol="0" anchor="t"/>
+          <a:lstStyle/>
+          <a:p>
+            <a:pPr algn="ctr" indent="0" marL="0">
+              <a:buNone/>
+            </a:pPr>
+            <a:r>
+              <a:rPr lang="en-US" sz="1300" b="1" spc="300" kern="0" dirty="0">
+                <a:solidFill>
+                  <a:srgbClr val="14213D"/>
+                </a:solidFill>
+                <a:latin typeface="Calibri" pitchFamily="34" charset="0"/>
+                <a:ea typeface="Calibri" pitchFamily="34" charset="-122"/>
+                <a:cs typeface="Calibri" pitchFamily="34" charset="-120"/>
+              </a:rPr>
+              <a:t>YEAR 2</a:t>
+            </a:r>
+            <a:endParaRPr lang="en-US" sz="1300" dirty="0"/>
+          </a:p>
+        </p:txBody>
+      </p:sp>
+      <p:sp>
+        <p:nvSpPr>
+          <p:cNvPr id="57" name="Text 52"/>
+          <p:cNvSpPr txBox="1"/>
+          <p:nvPr/>
+        </p:nvSpPr>
+        <p:spPr>
+          <a:xfrm>
+            <a:off x="10337800" y="5842000"/>
+            <a:ext cx="1270000" cy="215900"/>
+          </a:xfrm>
+          <a:prstGeom prst="rect">
+            <a:avLst/>
+          </a:prstGeom>
+          <a:noFill/>
+          <a:ln/>
+        </p:spPr>
+        <p:txBody>
+          <a:bodyPr wrap="square" lIns="0" tIns="0" rIns="0" bIns="0" rtlCol="0" anchor="t"/>
+          <a:lstStyle/>
+          <a:p>
+            <a:pPr algn="ctr" indent="0" marL="0">
+              <a:buNone/>
+            </a:pPr>
+            <a:r>
+              <a:rPr lang="en-US" sz="1300" b="1" spc="300" kern="0" dirty="0">
+                <a:solidFill>
+                  <a:srgbClr val="14213D"/>
+                </a:solidFill>
+                <a:latin typeface="Calibri" pitchFamily="34" charset="0"/>
+                <a:ea typeface="Calibri" pitchFamily="34" charset="-122"/>
+                <a:cs typeface="Calibri" pitchFamily="34" charset="-120"/>
+              </a:rPr>
+              <a:t>YEAR 3</a:t>
+            </a:r>
+            <a:endParaRPr lang="en-US" sz="1300" dirty="0"/>
+          </a:p>
+        </p:txBody>
+      </p:sp>
+      <p:sp>
+        <p:nvSpPr>
+          <p:cNvPr id="58" name="Text 53"/>
+          <p:cNvSpPr txBox="1"/>
+          <p:nvPr/>
+        </p:nvSpPr>
+        <p:spPr>
+          <a:xfrm>
+            <a:off x="3797300" y="4711700"/>
+            <a:ext cx="1905000" cy="215900"/>
+          </a:xfrm>
+          <a:prstGeom prst="rect">
+            <a:avLst/>
+          </a:prstGeom>
+          <a:noFill/>
+          <a:ln/>
+        </p:spPr>
+        <p:txBody>
+          <a:bodyPr wrap="square" lIns="0" tIns="0" rIns="0" bIns="0" rtlCol="0" anchor="t"/>
+          <a:lstStyle/>
+          <a:p>
+            <a:pPr indent="0" marL="0">
+              <a:buNone/>
+            </a:pPr>
+            <a:r>
+              <a:rPr lang="en-US" sz="1200" b="1" dirty="0">
+                <a:solidFill>
+                  <a:srgbClr val="3B4760"/>
+                </a:solidFill>
+                <a:latin typeface="Calibri" pitchFamily="34" charset="0"/>
+                <a:ea typeface="Calibri" pitchFamily="34" charset="-122"/>
+                <a:cs typeface="Calibri" pitchFamily="34" charset="-120"/>
+              </a:rPr>
+              <a:t>60 colleges · ₹1.45 Cr</a:t>
+            </a:r>
+            <a:endParaRPr lang="en-US" sz="1200" dirty="0"/>
+          </a:p>
+        </p:txBody>
+      </p:sp>
+      <p:sp>
+        <p:nvSpPr>
+          <p:cNvPr id="59" name="Text 54"/>
+          <p:cNvSpPr txBox="1"/>
+          <p:nvPr/>
+        </p:nvSpPr>
+        <p:spPr>
+          <a:xfrm>
+            <a:off x="6908800" y="3987800"/>
+            <a:ext cx="1905000" cy="215900"/>
+          </a:xfrm>
+          <a:prstGeom prst="rect">
+            <a:avLst/>
+          </a:prstGeom>
+          <a:noFill/>
+          <a:ln/>
+        </p:spPr>
+        <p:txBody>
+          <a:bodyPr wrap="square" lIns="0" tIns="0" rIns="0" bIns="0" rtlCol="0" anchor="t"/>
+          <a:lstStyle/>
+          <a:p>
+            <a:pPr indent="0" marL="0">
+              <a:buNone/>
+            </a:pPr>
+            <a:r>
+              <a:rPr lang="en-US" sz="1200" b="1" dirty="0">
+                <a:solidFill>
+                  <a:srgbClr val="3B4760"/>
+                </a:solidFill>
+                <a:latin typeface="Calibri" pitchFamily="34" charset="0"/>
+                <a:ea typeface="Calibri" pitchFamily="34" charset="-122"/>
+                <a:cs typeface="Calibri" pitchFamily="34" charset="-120"/>
+              </a:rPr>
+              <a:t>150 colleges · ₹3.6 Cr</a:t>
+            </a:r>
+            <a:endParaRPr lang="en-US" sz="1200" dirty="0"/>
+          </a:p>
+        </p:txBody>
+      </p:sp>
+      <p:sp>
+        <p:nvSpPr>
+          <p:cNvPr id="60" name="Text 55"/>
+          <p:cNvSpPr txBox="1"/>
+          <p:nvPr/>
+        </p:nvSpPr>
+        <p:spPr>
+          <a:xfrm>
+            <a:off x="9258300" y="2870200"/>
+            <a:ext cx="2095500" cy="215900"/>
+          </a:xfrm>
+          <a:prstGeom prst="rect">
+            <a:avLst/>
+          </a:prstGeom>
+          <a:noFill/>
+          <a:ln/>
+        </p:spPr>
+        <p:txBody>
+          <a:bodyPr wrap="square" lIns="0" tIns="0" rIns="0" bIns="0" rtlCol="0" anchor="t"/>
+          <a:lstStyle/>
+          <a:p>
+            <a:pPr algn="r" indent="0" marL="0">
+              <a:buNone/>
+            </a:pPr>
+            <a:r>
+              <a:rPr lang="en-US" sz="1200" b="1" dirty="0">
+                <a:solidFill>
+                  <a:srgbClr val="3B4760"/>
+                </a:solidFill>
+                <a:latin typeface="Calibri" pitchFamily="34" charset="0"/>
+                <a:ea typeface="Calibri" pitchFamily="34" charset="-122"/>
+                <a:cs typeface="Calibri" pitchFamily="34" charset="-120"/>
+              </a:rPr>
               <a:t>300 colleges · ₹7.3 Cr</a:t>
             </a:r>
             <a:endParaRPr lang="en-US" sz="1200" dirty="0"/>
@@ -4178,13 +4478,13 @@
       </p:sp>
       <p:sp>
         <p:nvSpPr>
-          <p:cNvPr id="12" name="Text 6"/>
+          <p:cNvPr id="61" name="Text 56"/>
           <p:cNvSpPr txBox="1"/>
           <p:nvPr/>
         </p:nvSpPr>
         <p:spPr>
           <a:xfrm rot="-120000">
-            <a:off x="7810500" y="4826000"/>
+            <a:off x="8178800" y="5080000"/>
             <a:ext cx="2921000" cy="355600"/>
           </a:xfrm>
           <a:prstGeom prst="roundRect">
@@ -4232,7 +4532,7 @@
       </p:sp>
       <p:sp>
         <p:nvSpPr>
-          <p:cNvPr id="13" name="Text 7"/>
+          <p:cNvPr id="62" name="Text 57"/>
           <p:cNvSpPr txBox="1"/>
           <p:nvPr/>
         </p:nvSpPr>
@@ -6181,7 +6481,9 @@
           <a:noFill/>
           <a:ln w="44450">
             <a:solidFill>
-              <a:srgbClr val="0F7B4C"/>
+              <a:srgbClr val="0F7B4C">
+                <a:alpha val="40000"/>
+              </a:srgbClr>
             </a:solidFill>
             <a:prstDash val="solid"/>
           </a:ln>
@@ -6204,7 +6506,9 @@
           <a:noFill/>
           <a:ln w="44450">
             <a:solidFill>
-              <a:srgbClr val="0F7B4C"/>
+              <a:srgbClr val="0F7B4C">
+                <a:alpha val="40000"/>
+              </a:srgbClr>
             </a:solidFill>
             <a:prstDash val="solid"/>
           </a:ln>
@@ -6227,7 +6531,9 @@
           <a:noFill/>
           <a:ln w="44450">
             <a:solidFill>
-              <a:srgbClr val="0F7B4C"/>
+              <a:srgbClr val="0F7B4C">
+                <a:alpha val="40000"/>
+              </a:srgbClr>
             </a:solidFill>
             <a:prstDash val="solid"/>
           </a:ln>
@@ -6250,7 +6556,9 @@
           <a:noFill/>
           <a:ln w="44450">
             <a:solidFill>
-              <a:srgbClr val="0F7B4C"/>
+              <a:srgbClr val="0F7B4C">
+                <a:alpha val="40000"/>
+              </a:srgbClr>
             </a:solidFill>
             <a:prstDash val="solid"/>
           </a:ln>
@@ -6273,7 +6581,9 @@
           <a:noFill/>
           <a:ln w="44450">
             <a:solidFill>
-              <a:srgbClr val="0F7B4C"/>
+              <a:srgbClr val="0F7B4C">
+                <a:alpha val="40000"/>
+              </a:srgbClr>
             </a:solidFill>
             <a:prstDash val="solid"/>
           </a:ln>
@@ -6296,7 +6606,9 @@
           <a:noFill/>
           <a:ln w="44450">
             <a:solidFill>
-              <a:srgbClr val="0F7B4C"/>
+              <a:srgbClr val="0F7B4C">
+                <a:alpha val="40000"/>
+              </a:srgbClr>
             </a:solidFill>
             <a:prstDash val="solid"/>
           </a:ln>
@@ -6319,7 +6631,9 @@
           <a:noFill/>
           <a:ln w="44450">
             <a:solidFill>
-              <a:srgbClr val="0F7B4C"/>
+              <a:srgbClr val="0F7B4C">
+                <a:alpha val="40000"/>
+              </a:srgbClr>
             </a:solidFill>
             <a:prstDash val="solid"/>
           </a:ln>
@@ -6342,7 +6656,9 @@
           <a:noFill/>
           <a:ln w="44450">
             <a:solidFill>
-              <a:srgbClr val="0F7B4C"/>
+              <a:srgbClr val="0F7B4C">
+                <a:alpha val="40000"/>
+              </a:srgbClr>
             </a:solidFill>
             <a:prstDash val="solid"/>
           </a:ln>
@@ -6365,7 +6681,9 @@
           <a:noFill/>
           <a:ln w="44450">
             <a:solidFill>
-              <a:srgbClr val="0F7B4C"/>
+              <a:srgbClr val="0F7B4C">
+                <a:alpha val="40000"/>
+              </a:srgbClr>
             </a:solidFill>
             <a:prstDash val="solid"/>
           </a:ln>
@@ -6388,7 +6706,9 @@
           <a:noFill/>
           <a:ln w="44450">
             <a:solidFill>
-              <a:srgbClr val="0F7B4C"/>
+              <a:srgbClr val="0F7B4C">
+                <a:alpha val="40000"/>
+              </a:srgbClr>
             </a:solidFill>
             <a:prstDash val="solid"/>
           </a:ln>
@@ -6411,7 +6731,9 @@
           <a:noFill/>
           <a:ln w="44450">
             <a:solidFill>
-              <a:srgbClr val="0F7B4C"/>
+              <a:srgbClr val="0F7B4C">
+                <a:alpha val="40000"/>
+              </a:srgbClr>
             </a:solidFill>
             <a:prstDash val="solid"/>
           </a:ln>
@@ -6434,7 +6756,9 @@
           <a:noFill/>
           <a:ln w="44450">
             <a:solidFill>
-              <a:srgbClr val="0F7B4C"/>
+              <a:srgbClr val="0F7B4C">
+                <a:alpha val="40000"/>
+              </a:srgbClr>
             </a:solidFill>
             <a:prstDash val="solid"/>
           </a:ln>
@@ -6457,7 +6781,9 @@
           <a:noFill/>
           <a:ln w="44450">
             <a:solidFill>
-              <a:srgbClr val="0F7B4C"/>
+              <a:srgbClr val="0F7B4C">
+                <a:alpha val="40000"/>
+              </a:srgbClr>
             </a:solidFill>
             <a:prstDash val="solid"/>
           </a:ln>
@@ -6866,11 +7192,15 @@
             <a:avLst/>
           </a:prstGeom>
           <a:solidFill>
-            <a:srgbClr val="C1272D"/>
+            <a:srgbClr val="C1272D">
+              <a:alpha val="8000"/>
+            </a:srgbClr>
           </a:solidFill>
           <a:ln w="12700">
             <a:solidFill>
-              <a:srgbClr val="C1272D"/>
+              <a:srgbClr val="C1272D">
+                <a:alpha val="0"/>
+              </a:srgbClr>
             </a:solidFill>
             <a:prstDash val="solid"/>
           </a:ln>
@@ -10782,8 +11112,8 @@
         </p:nvSpPr>
         <p:spPr>
           <a:xfrm>
-            <a:off x="812800" y="1238250"/>
-            <a:ext cx="4064000" cy="1079500"/>
+            <a:off x="812800" y="1206500"/>
+            <a:ext cx="4064000" cy="1270000"/>
           </a:xfrm>
           <a:prstGeom prst="rect">
             <a:avLst/>
@@ -10802,7 +11132,7 @@
               <a:buNone/>
             </a:pPr>
             <a:r>
-              <a:rPr lang="en-US" sz="3600" dirty="0">
+              <a:rPr lang="en-US" sz="2900" dirty="0">
                 <a:solidFill>
                   <a:srgbClr val="14213D"/>
                 </a:solidFill>
@@ -10812,7 +11142,7 @@
               </a:rPr>
               <a:t>Trade the real market. Lose nothing.</a:t>
             </a:r>
-            <a:endParaRPr lang="en-US" sz="3600" dirty="0"/>
+            <a:endParaRPr lang="en-US" sz="2900" dirty="0"/>
           </a:p>
         </p:txBody>
       </p:sp>
@@ -14818,25 +15148,741 @@
           </a:p>
         </p:txBody>
       </p:sp>
-      <p:graphicFrame>
-        <p:nvGraphicFramePr>
-          <p:cNvPr id="7" name="Chart 0" descr=""/>
-          <p:cNvGraphicFramePr/>
-          <p:nvPr/>
-        </p:nvGraphicFramePr>
-        <p:xfrm>
-          <a:off x="812800" y="1905000"/>
-          <a:ext cx="6096000" cy="4064000"/>
-        </p:xfrm>
-        <a:graphic xmlns:a="http://schemas.openxmlformats.org/drawingml/2006/main">
-          <a:graphicData uri="http://schemas.openxmlformats.org/drawingml/2006/chart">
-            <c:chart xmlns:c="http://schemas.openxmlformats.org/drawingml/2006/chart" r:id="rId3"/>
-          </a:graphicData>
-        </a:graphic>
-      </p:graphicFrame>
-      <p:sp>
-        <p:nvSpPr>
-          <p:cNvPr id="8" name="Shape 2"/>
+      <p:sp>
+        <p:nvSpPr>
+          <p:cNvPr id="7" name="Shape 2"/>
+          <p:cNvSpPr/>
+          <p:nvPr/>
+        </p:nvSpPr>
+        <p:spPr>
+          <a:xfrm>
+            <a:off x="812800" y="5461000"/>
+            <a:ext cx="6096000" cy="19050"/>
+          </a:xfrm>
+          <a:prstGeom prst="rect">
+            <a:avLst/>
+          </a:prstGeom>
+          <a:solidFill>
+            <a:srgbClr val="14213D"/>
+          </a:solidFill>
+          <a:ln w="12700">
+            <a:solidFill>
+              <a:srgbClr val="14213D"/>
+            </a:solidFill>
+            <a:prstDash val="solid"/>
+          </a:ln>
+        </p:spPr>
+      </p:sp>
+      <p:sp>
+        <p:nvSpPr>
+          <p:cNvPr id="8" name="Shape 3"/>
+          <p:cNvSpPr/>
+          <p:nvPr/>
+        </p:nvSpPr>
+        <p:spPr>
+          <a:xfrm>
+            <a:off x="1320800" y="2857500"/>
+            <a:ext cx="1397000" cy="2603500"/>
+          </a:xfrm>
+          <a:prstGeom prst="rect">
+            <a:avLst/>
+          </a:prstGeom>
+          <a:solidFill>
+            <a:srgbClr val="0F7B4C"/>
+          </a:solidFill>
+          <a:ln w="12700">
+            <a:solidFill>
+              <a:srgbClr val="0F7B4C"/>
+            </a:solidFill>
+            <a:prstDash val="solid"/>
+          </a:ln>
+        </p:spPr>
+      </p:sp>
+      <p:sp>
+        <p:nvSpPr>
+          <p:cNvPr id="9" name="Shape 4"/>
+          <p:cNvSpPr/>
+          <p:nvPr/>
+        </p:nvSpPr>
+        <p:spPr>
+          <a:xfrm>
+            <a:off x="1320800" y="2501900"/>
+            <a:ext cx="1397000" cy="342900"/>
+          </a:xfrm>
+          <a:prstGeom prst="rect">
+            <a:avLst/>
+          </a:prstGeom>
+          <a:solidFill>
+            <a:srgbClr val="E8A800"/>
+          </a:solidFill>
+          <a:ln w="12700">
+            <a:solidFill>
+              <a:srgbClr val="E8A800"/>
+            </a:solidFill>
+            <a:prstDash val="solid"/>
+          </a:ln>
+        </p:spPr>
+      </p:sp>
+      <p:sp>
+        <p:nvSpPr>
+          <p:cNvPr id="10" name="Shape 5"/>
+          <p:cNvSpPr/>
+          <p:nvPr/>
+        </p:nvSpPr>
+        <p:spPr>
+          <a:xfrm>
+            <a:off x="1320800" y="2273300"/>
+            <a:ext cx="1397000" cy="215900"/>
+          </a:xfrm>
+          <a:prstGeom prst="rect">
+            <a:avLst/>
+          </a:prstGeom>
+          <a:solidFill>
+            <a:srgbClr val="14213D"/>
+          </a:solidFill>
+          <a:ln w="12700">
+            <a:solidFill>
+              <a:srgbClr val="14213D"/>
+            </a:solidFill>
+            <a:prstDash val="solid"/>
+          </a:ln>
+        </p:spPr>
+      </p:sp>
+      <p:sp>
+        <p:nvSpPr>
+          <p:cNvPr id="11" name="Text 6"/>
+          <p:cNvSpPr txBox="1"/>
+          <p:nvPr/>
+        </p:nvSpPr>
+        <p:spPr>
+          <a:xfrm>
+            <a:off x="2844800" y="4000500"/>
+            <a:ext cx="1905000" cy="228600"/>
+          </a:xfrm>
+          <a:prstGeom prst="rect">
+            <a:avLst/>
+          </a:prstGeom>
+          <a:noFill/>
+          <a:ln/>
+        </p:spPr>
+        <p:txBody>
+          <a:bodyPr wrap="square" lIns="0" tIns="0" rIns="0" bIns="0" rtlCol="0" anchor="t"/>
+          <a:lstStyle/>
+          <a:p>
+            <a:pPr indent="0" marL="0">
+              <a:buNone/>
+            </a:pPr>
+            <a:r>
+              <a:rPr lang="en-US" sz="1400" b="1" dirty="0">
+                <a:solidFill>
+                  <a:srgbClr val="14213D"/>
+                </a:solidFill>
+                <a:latin typeface="Calibri" pitchFamily="34" charset="0"/>
+                <a:ea typeface="Calibri" pitchFamily="34" charset="-122"/>
+                <a:cs typeface="Calibri" pitchFamily="34" charset="-120"/>
+              </a:rPr>
+              <a:t>Institutions</a:t>
+            </a:r>
+            <a:endParaRPr lang="en-US" sz="1400" dirty="0"/>
+          </a:p>
+        </p:txBody>
+      </p:sp>
+      <p:sp>
+        <p:nvSpPr>
+          <p:cNvPr id="12" name="Text 7"/>
+          <p:cNvSpPr txBox="1"/>
+          <p:nvPr/>
+        </p:nvSpPr>
+        <p:spPr>
+          <a:xfrm>
+            <a:off x="2844800" y="4229100"/>
+            <a:ext cx="1905000" cy="228600"/>
+          </a:xfrm>
+          <a:prstGeom prst="rect">
+            <a:avLst/>
+          </a:prstGeom>
+          <a:noFill/>
+          <a:ln/>
+        </p:spPr>
+        <p:txBody>
+          <a:bodyPr wrap="square" lIns="0" tIns="0" rIns="0" bIns="0" rtlCol="0" anchor="t"/>
+          <a:lstStyle/>
+          <a:p>
+            <a:pPr indent="0" marL="0">
+              <a:buNone/>
+            </a:pPr>
+            <a:r>
+              <a:rPr lang="en-US" sz="1400" b="1" dirty="0">
+                <a:solidFill>
+                  <a:srgbClr val="0F7B4C"/>
+                </a:solidFill>
+                <a:latin typeface="Calibri" pitchFamily="34" charset="0"/>
+                <a:ea typeface="Calibri" pitchFamily="34" charset="-122"/>
+                <a:cs typeface="Calibri" pitchFamily="34" charset="-120"/>
+              </a:rPr>
+              <a:t>₹1.19 Cr</a:t>
+            </a:r>
+            <a:endParaRPr lang="en-US" sz="1400" dirty="0"/>
+          </a:p>
+        </p:txBody>
+      </p:sp>
+      <p:sp>
+        <p:nvSpPr>
+          <p:cNvPr id="13" name="Text 8"/>
+          <p:cNvSpPr txBox="1"/>
+          <p:nvPr/>
+        </p:nvSpPr>
+        <p:spPr>
+          <a:xfrm>
+            <a:off x="2844800" y="2565400"/>
+            <a:ext cx="1905000" cy="215900"/>
+          </a:xfrm>
+          <a:prstGeom prst="rect">
+            <a:avLst/>
+          </a:prstGeom>
+          <a:noFill/>
+          <a:ln/>
+        </p:spPr>
+        <p:txBody>
+          <a:bodyPr wrap="square" lIns="0" tIns="0" rIns="0" bIns="0" rtlCol="0" anchor="t"/>
+          <a:lstStyle/>
+          <a:p>
+            <a:pPr indent="0" marL="0">
+              <a:buNone/>
+            </a:pPr>
+            <a:r>
+              <a:rPr lang="en-US" sz="1300" b="1" dirty="0">
+                <a:solidFill>
+                  <a:srgbClr val="14213D"/>
+                </a:solidFill>
+                <a:latin typeface="Calibri" pitchFamily="34" charset="0"/>
+                <a:ea typeface="Calibri" pitchFamily="34" charset="-122"/>
+                <a:cs typeface="Calibri" pitchFamily="34" charset="-120"/>
+              </a:rPr>
+              <a:t>Ads · ₹15.6 L</a:t>
+            </a:r>
+            <a:endParaRPr lang="en-US" sz="1300" dirty="0"/>
+          </a:p>
+        </p:txBody>
+      </p:sp>
+      <p:sp>
+        <p:nvSpPr>
+          <p:cNvPr id="14" name="Text 9"/>
+          <p:cNvSpPr txBox="1"/>
+          <p:nvPr/>
+        </p:nvSpPr>
+        <p:spPr>
+          <a:xfrm>
+            <a:off x="1320800" y="1993900"/>
+            <a:ext cx="2540000" cy="215900"/>
+          </a:xfrm>
+          <a:prstGeom prst="rect">
+            <a:avLst/>
+          </a:prstGeom>
+          <a:noFill/>
+          <a:ln/>
+        </p:spPr>
+        <p:txBody>
+          <a:bodyPr wrap="square" lIns="0" tIns="0" rIns="0" bIns="0" rtlCol="0" anchor="t"/>
+          <a:lstStyle/>
+          <a:p>
+            <a:pPr indent="0" marL="0">
+              <a:buNone/>
+            </a:pPr>
+            <a:r>
+              <a:rPr lang="en-US" sz="1300" b="1" dirty="0">
+                <a:solidFill>
+                  <a:srgbClr val="14213D"/>
+                </a:solidFill>
+                <a:latin typeface="Calibri" pitchFamily="34" charset="0"/>
+                <a:ea typeface="Calibri" pitchFamily="34" charset="-122"/>
+                <a:cs typeface="Calibri" pitchFamily="34" charset="-120"/>
+              </a:rPr>
+              <a:t>Paid individuals · ₹10 L</a:t>
+            </a:r>
+            <a:endParaRPr lang="en-US" sz="1300" dirty="0"/>
+          </a:p>
+        </p:txBody>
+      </p:sp>
+      <p:sp>
+        <p:nvSpPr>
+          <p:cNvPr id="15" name="Text 10"/>
+          <p:cNvSpPr txBox="1"/>
+          <p:nvPr/>
+        </p:nvSpPr>
+        <p:spPr>
+          <a:xfrm>
+            <a:off x="1066800" y="5575300"/>
+            <a:ext cx="1905000" cy="317500"/>
+          </a:xfrm>
+          <a:prstGeom prst="rect">
+            <a:avLst/>
+          </a:prstGeom>
+          <a:noFill/>
+          <a:ln/>
+        </p:spPr>
+        <p:txBody>
+          <a:bodyPr wrap="square" lIns="0" tIns="0" rIns="0" bIns="0" rtlCol="0" anchor="t"/>
+          <a:lstStyle/>
+          <a:p>
+            <a:pPr algn="ctr" indent="0" marL="0">
+              <a:buNone/>
+            </a:pPr>
+            <a:r>
+              <a:rPr lang="en-US" sz="2200" dirty="0">
+                <a:solidFill>
+                  <a:srgbClr val="14213D"/>
+                </a:solidFill>
+                <a:latin typeface="Cambria" pitchFamily="34" charset="0"/>
+                <a:ea typeface="Cambria" pitchFamily="34" charset="-122"/>
+                <a:cs typeface="Cambria" pitchFamily="34" charset="-120"/>
+              </a:rPr>
+              <a:t>₹1.45 Cr</a:t>
+            </a:r>
+            <a:endParaRPr lang="en-US" sz="2200" dirty="0"/>
+          </a:p>
+        </p:txBody>
+      </p:sp>
+      <p:sp>
+        <p:nvSpPr>
+          <p:cNvPr id="16" name="Text 11"/>
+          <p:cNvSpPr txBox="1"/>
+          <p:nvPr/>
+        </p:nvSpPr>
+        <p:spPr>
+          <a:xfrm>
+            <a:off x="1066800" y="5880100"/>
+            <a:ext cx="1905000" cy="190500"/>
+          </a:xfrm>
+          <a:prstGeom prst="rect">
+            <a:avLst/>
+          </a:prstGeom>
+          <a:noFill/>
+          <a:ln/>
+        </p:spPr>
+        <p:txBody>
+          <a:bodyPr wrap="square" lIns="0" tIns="0" rIns="0" bIns="0" rtlCol="0" anchor="t"/>
+          <a:lstStyle/>
+          <a:p>
+            <a:pPr algn="ctr" indent="0" marL="0">
+              <a:buNone/>
+            </a:pPr>
+            <a:r>
+              <a:rPr lang="en-US" sz="1200" b="1" spc="300" kern="0" dirty="0">
+                <a:solidFill>
+                  <a:srgbClr val="0F7B4C"/>
+                </a:solidFill>
+                <a:latin typeface="Calibri" pitchFamily="34" charset="0"/>
+                <a:ea typeface="Calibri" pitchFamily="34" charset="-122"/>
+                <a:cs typeface="Calibri" pitchFamily="34" charset="-120"/>
+              </a:rPr>
+              <a:t>REVENUE</a:t>
+            </a:r>
+            <a:endParaRPr lang="en-US" sz="1200" dirty="0"/>
+          </a:p>
+        </p:txBody>
+      </p:sp>
+      <p:sp>
+        <p:nvSpPr>
+          <p:cNvPr id="17" name="Shape 12"/>
+          <p:cNvSpPr/>
+          <p:nvPr/>
+        </p:nvSpPr>
+        <p:spPr>
+          <a:xfrm>
+            <a:off x="4241800" y="4540250"/>
+            <a:ext cx="1397000" cy="920750"/>
+          </a:xfrm>
+          <a:prstGeom prst="rect">
+            <a:avLst/>
+          </a:prstGeom>
+          <a:solidFill>
+            <a:srgbClr val="C1272D"/>
+          </a:solidFill>
+          <a:ln w="12700">
+            <a:solidFill>
+              <a:srgbClr val="C1272D"/>
+            </a:solidFill>
+            <a:prstDash val="solid"/>
+          </a:ln>
+        </p:spPr>
+      </p:sp>
+      <p:sp>
+        <p:nvSpPr>
+          <p:cNvPr id="18" name="Text 13"/>
+          <p:cNvSpPr txBox="1"/>
+          <p:nvPr/>
+        </p:nvSpPr>
+        <p:spPr>
+          <a:xfrm>
+            <a:off x="5765800" y="4889500"/>
+            <a:ext cx="1143000" cy="215900"/>
+          </a:xfrm>
+          <a:prstGeom prst="rect">
+            <a:avLst/>
+          </a:prstGeom>
+          <a:noFill/>
+          <a:ln/>
+        </p:spPr>
+        <p:txBody>
+          <a:bodyPr wrap="square" lIns="0" tIns="0" rIns="0" bIns="0" rtlCol="0" anchor="t"/>
+          <a:lstStyle/>
+          <a:p>
+            <a:pPr indent="0" marL="0">
+              <a:buNone/>
+            </a:pPr>
+            <a:r>
+              <a:rPr lang="en-US" sz="1300" b="1" dirty="0">
+                <a:solidFill>
+                  <a:srgbClr val="14213D"/>
+                </a:solidFill>
+                <a:latin typeface="Calibri" pitchFamily="34" charset="0"/>
+                <a:ea typeface="Calibri" pitchFamily="34" charset="-122"/>
+                <a:cs typeface="Calibri" pitchFamily="34" charset="-120"/>
+              </a:rPr>
+              <a:t>Team ₹42 L</a:t>
+            </a:r>
+            <a:endParaRPr lang="en-US" sz="1300" dirty="0"/>
+          </a:p>
+        </p:txBody>
+      </p:sp>
+      <p:sp>
+        <p:nvSpPr>
+          <p:cNvPr id="19" name="Shape 14"/>
+          <p:cNvSpPr/>
+          <p:nvPr/>
+        </p:nvSpPr>
+        <p:spPr>
+          <a:xfrm>
+            <a:off x="4241800" y="3473450"/>
+            <a:ext cx="1397000" cy="1054100"/>
+          </a:xfrm>
+          <a:prstGeom prst="rect">
+            <a:avLst/>
+          </a:prstGeom>
+          <a:solidFill>
+            <a:srgbClr val="D9534F"/>
+          </a:solidFill>
+          <a:ln w="12700">
+            <a:solidFill>
+              <a:srgbClr val="D9534F"/>
+            </a:solidFill>
+            <a:prstDash val="solid"/>
+          </a:ln>
+        </p:spPr>
+      </p:sp>
+      <p:sp>
+        <p:nvSpPr>
+          <p:cNvPr id="20" name="Text 15"/>
+          <p:cNvSpPr txBox="1"/>
+          <p:nvPr/>
+        </p:nvSpPr>
+        <p:spPr>
+          <a:xfrm>
+            <a:off x="5765800" y="3892550"/>
+            <a:ext cx="1143000" cy="215900"/>
+          </a:xfrm>
+          <a:prstGeom prst="rect">
+            <a:avLst/>
+          </a:prstGeom>
+          <a:noFill/>
+          <a:ln/>
+        </p:spPr>
+        <p:txBody>
+          <a:bodyPr wrap="square" lIns="0" tIns="0" rIns="0" bIns="0" rtlCol="0" anchor="t"/>
+          <a:lstStyle/>
+          <a:p>
+            <a:pPr indent="0" marL="0">
+              <a:buNone/>
+            </a:pPr>
+            <a:r>
+              <a:rPr lang="en-US" sz="1300" b="1" dirty="0">
+                <a:solidFill>
+                  <a:srgbClr val="14213D"/>
+                </a:solidFill>
+                <a:latin typeface="Calibri" pitchFamily="34" charset="0"/>
+                <a:ea typeface="Calibri" pitchFamily="34" charset="-122"/>
+                <a:cs typeface="Calibri" pitchFamily="34" charset="-120"/>
+              </a:rPr>
+              <a:t>Sales ₹48 L</a:t>
+            </a:r>
+            <a:endParaRPr lang="en-US" sz="1300" dirty="0"/>
+          </a:p>
+        </p:txBody>
+      </p:sp>
+      <p:sp>
+        <p:nvSpPr>
+          <p:cNvPr id="21" name="Shape 16"/>
+          <p:cNvSpPr/>
+          <p:nvPr/>
+        </p:nvSpPr>
+        <p:spPr>
+          <a:xfrm>
+            <a:off x="4241800" y="2806700"/>
+            <a:ext cx="1397000" cy="654050"/>
+          </a:xfrm>
+          <a:prstGeom prst="rect">
+            <a:avLst/>
+          </a:prstGeom>
+          <a:solidFill>
+            <a:srgbClr val="E8807C"/>
+          </a:solidFill>
+          <a:ln w="12700">
+            <a:solidFill>
+              <a:srgbClr val="E8807C"/>
+            </a:solidFill>
+            <a:prstDash val="solid"/>
+          </a:ln>
+        </p:spPr>
+      </p:sp>
+      <p:sp>
+        <p:nvSpPr>
+          <p:cNvPr id="22" name="Text 17"/>
+          <p:cNvSpPr txBox="1"/>
+          <p:nvPr/>
+        </p:nvSpPr>
+        <p:spPr>
+          <a:xfrm>
+            <a:off x="5765800" y="3022600"/>
+            <a:ext cx="1143000" cy="215900"/>
+          </a:xfrm>
+          <a:prstGeom prst="rect">
+            <a:avLst/>
+          </a:prstGeom>
+          <a:noFill/>
+          <a:ln/>
+        </p:spPr>
+        <p:txBody>
+          <a:bodyPr wrap="square" lIns="0" tIns="0" rIns="0" bIns="0" rtlCol="0" anchor="t"/>
+          <a:lstStyle/>
+          <a:p>
+            <a:pPr indent="0" marL="0">
+              <a:buNone/>
+            </a:pPr>
+            <a:r>
+              <a:rPr lang="en-US" sz="1300" b="1" dirty="0">
+                <a:solidFill>
+                  <a:srgbClr val="14213D"/>
+                </a:solidFill>
+                <a:latin typeface="Calibri" pitchFamily="34" charset="0"/>
+                <a:ea typeface="Calibri" pitchFamily="34" charset="-122"/>
+                <a:cs typeface="Calibri" pitchFamily="34" charset="-120"/>
+              </a:rPr>
+              <a:t>Cloud ₹30 L</a:t>
+            </a:r>
+            <a:endParaRPr lang="en-US" sz="1300" dirty="0"/>
+          </a:p>
+        </p:txBody>
+      </p:sp>
+      <p:sp>
+        <p:nvSpPr>
+          <p:cNvPr id="23" name="Shape 18"/>
+          <p:cNvSpPr/>
+          <p:nvPr/>
+        </p:nvSpPr>
+        <p:spPr>
+          <a:xfrm>
+            <a:off x="4241800" y="2578100"/>
+            <a:ext cx="1397000" cy="215900"/>
+          </a:xfrm>
+          <a:prstGeom prst="rect">
+            <a:avLst/>
+          </a:prstGeom>
+          <a:solidFill>
+            <a:srgbClr val="F2ADAA"/>
+          </a:solidFill>
+          <a:ln w="12700">
+            <a:solidFill>
+              <a:srgbClr val="F2ADAA"/>
+            </a:solidFill>
+            <a:prstDash val="solid"/>
+          </a:ln>
+        </p:spPr>
+      </p:sp>
+      <p:sp>
+        <p:nvSpPr>
+          <p:cNvPr id="24" name="Text 19"/>
+          <p:cNvSpPr txBox="1"/>
+          <p:nvPr/>
+        </p:nvSpPr>
+        <p:spPr>
+          <a:xfrm>
+            <a:off x="5765800" y="2578100"/>
+            <a:ext cx="1143000" cy="215900"/>
+          </a:xfrm>
+          <a:prstGeom prst="rect">
+            <a:avLst/>
+          </a:prstGeom>
+          <a:noFill/>
+          <a:ln/>
+        </p:spPr>
+        <p:txBody>
+          <a:bodyPr wrap="square" lIns="0" tIns="0" rIns="0" bIns="0" rtlCol="0" anchor="t"/>
+          <a:lstStyle/>
+          <a:p>
+            <a:pPr indent="0" marL="0">
+              <a:buNone/>
+            </a:pPr>
+            <a:r>
+              <a:rPr lang="en-US" sz="1300" b="1" dirty="0">
+                <a:solidFill>
+                  <a:srgbClr val="14213D"/>
+                </a:solidFill>
+                <a:latin typeface="Calibri" pitchFamily="34" charset="0"/>
+                <a:ea typeface="Calibri" pitchFamily="34" charset="-122"/>
+                <a:cs typeface="Calibri" pitchFamily="34" charset="-120"/>
+              </a:rPr>
+              <a:t>Data ₹10 L</a:t>
+            </a:r>
+            <a:endParaRPr lang="en-US" sz="1300" dirty="0"/>
+          </a:p>
+        </p:txBody>
+      </p:sp>
+      <p:sp>
+        <p:nvSpPr>
+          <p:cNvPr id="25" name="Shape 20"/>
+          <p:cNvSpPr/>
+          <p:nvPr/>
+        </p:nvSpPr>
+        <p:spPr>
+          <a:xfrm>
+            <a:off x="4241800" y="2349500"/>
+            <a:ext cx="1397000" cy="215900"/>
+          </a:xfrm>
+          <a:prstGeom prst="rect">
+            <a:avLst/>
+          </a:prstGeom>
+          <a:solidFill>
+            <a:srgbClr val="F8D7D5"/>
+          </a:solidFill>
+          <a:ln w="12700">
+            <a:solidFill>
+              <a:srgbClr val="F8D7D5"/>
+            </a:solidFill>
+            <a:prstDash val="solid"/>
+          </a:ln>
+        </p:spPr>
+      </p:sp>
+      <p:sp>
+        <p:nvSpPr>
+          <p:cNvPr id="26" name="Text 21"/>
+          <p:cNvSpPr txBox="1"/>
+          <p:nvPr/>
+        </p:nvSpPr>
+        <p:spPr>
+          <a:xfrm>
+            <a:off x="5765800" y="2349500"/>
+            <a:ext cx="1143000" cy="215900"/>
+          </a:xfrm>
+          <a:prstGeom prst="rect">
+            <a:avLst/>
+          </a:prstGeom>
+          <a:noFill/>
+          <a:ln/>
+        </p:spPr>
+        <p:txBody>
+          <a:bodyPr wrap="square" lIns="0" tIns="0" rIns="0" bIns="0" rtlCol="0" anchor="t"/>
+          <a:lstStyle/>
+          <a:p>
+            <a:pPr indent="0" marL="0">
+              <a:buNone/>
+            </a:pPr>
+            <a:r>
+              <a:rPr lang="en-US" sz="1300" b="1" dirty="0">
+                <a:solidFill>
+                  <a:srgbClr val="14213D"/>
+                </a:solidFill>
+                <a:latin typeface="Calibri" pitchFamily="34" charset="0"/>
+                <a:ea typeface="Calibri" pitchFamily="34" charset="-122"/>
+                <a:cs typeface="Calibri" pitchFamily="34" charset="-120"/>
+              </a:rPr>
+              <a:t>Ops ₹10 L</a:t>
+            </a:r>
+            <a:endParaRPr lang="en-US" sz="1300" dirty="0"/>
+          </a:p>
+        </p:txBody>
+      </p:sp>
+      <p:sp>
+        <p:nvSpPr>
+          <p:cNvPr id="27" name="Text 22"/>
+          <p:cNvSpPr txBox="1"/>
+          <p:nvPr/>
+        </p:nvSpPr>
+        <p:spPr>
+          <a:xfrm>
+            <a:off x="3987800" y="5575300"/>
+            <a:ext cx="1905000" cy="317500"/>
+          </a:xfrm>
+          <a:prstGeom prst="rect">
+            <a:avLst/>
+          </a:prstGeom>
+          <a:noFill/>
+          <a:ln/>
+        </p:spPr>
+        <p:txBody>
+          <a:bodyPr wrap="square" lIns="0" tIns="0" rIns="0" bIns="0" rtlCol="0" anchor="t"/>
+          <a:lstStyle/>
+          <a:p>
+            <a:pPr algn="ctr" indent="0" marL="0">
+              <a:buNone/>
+            </a:pPr>
+            <a:r>
+              <a:rPr lang="en-US" sz="2200" dirty="0">
+                <a:solidFill>
+                  <a:srgbClr val="14213D"/>
+                </a:solidFill>
+                <a:latin typeface="Cambria" pitchFamily="34" charset="0"/>
+                <a:ea typeface="Cambria" pitchFamily="34" charset="-122"/>
+                <a:cs typeface="Cambria" pitchFamily="34" charset="-120"/>
+              </a:rPr>
+              <a:t>₹1.40 Cr</a:t>
+            </a:r>
+            <a:endParaRPr lang="en-US" sz="2200" dirty="0"/>
+          </a:p>
+        </p:txBody>
+      </p:sp>
+      <p:sp>
+        <p:nvSpPr>
+          <p:cNvPr id="28" name="Text 23"/>
+          <p:cNvSpPr txBox="1"/>
+          <p:nvPr/>
+        </p:nvSpPr>
+        <p:spPr>
+          <a:xfrm>
+            <a:off x="3987800" y="5880100"/>
+            <a:ext cx="1905000" cy="190500"/>
+          </a:xfrm>
+          <a:prstGeom prst="rect">
+            <a:avLst/>
+          </a:prstGeom>
+          <a:noFill/>
+          <a:ln/>
+        </p:spPr>
+        <p:txBody>
+          <a:bodyPr wrap="square" lIns="0" tIns="0" rIns="0" bIns="0" rtlCol="0" anchor="t"/>
+          <a:lstStyle/>
+          <a:p>
+            <a:pPr algn="ctr" indent="0" marL="0">
+              <a:buNone/>
+            </a:pPr>
+            <a:r>
+              <a:rPr lang="en-US" sz="1200" b="1" spc="300" kern="0" dirty="0">
+                <a:solidFill>
+                  <a:srgbClr val="C1272D"/>
+                </a:solidFill>
+                <a:latin typeface="Calibri" pitchFamily="34" charset="0"/>
+                <a:ea typeface="Calibri" pitchFamily="34" charset="-122"/>
+                <a:cs typeface="Calibri" pitchFamily="34" charset="-120"/>
+              </a:rPr>
+              <a:t>COST · YEAR 1</a:t>
+            </a:r>
+            <a:endParaRPr lang="en-US" sz="1200" dirty="0"/>
+          </a:p>
+        </p:txBody>
+      </p:sp>
+      <p:sp>
+        <p:nvSpPr>
+          <p:cNvPr id="29" name="Shape 24"/>
           <p:cNvSpPr/>
           <p:nvPr/>
         </p:nvSpPr>
@@ -14859,7 +15905,7 @@
       </p:sp>
       <p:sp>
         <p:nvSpPr>
-          <p:cNvPr id="9" name="Text 3"/>
+          <p:cNvPr id="30" name="Text 25"/>
           <p:cNvSpPr txBox="1"/>
           <p:nvPr/>
         </p:nvSpPr>
@@ -14901,7 +15947,7 @@
       </p:sp>
       <p:sp>
         <p:nvSpPr>
-          <p:cNvPr id="10" name="Text 4"/>
+          <p:cNvPr id="31" name="Text 26"/>
           <p:cNvSpPr txBox="1"/>
           <p:nvPr/>
         </p:nvSpPr>
@@ -14943,7 +15989,7 @@
       </p:sp>
       <p:sp>
         <p:nvSpPr>
-          <p:cNvPr id="11" name="Shape 5"/>
+          <p:cNvPr id="32" name="Shape 27"/>
           <p:cNvSpPr/>
           <p:nvPr/>
         </p:nvSpPr>
@@ -14966,7 +16012,7 @@
       </p:sp>
       <p:sp>
         <p:nvSpPr>
-          <p:cNvPr id="12" name="Text 6"/>
+          <p:cNvPr id="33" name="Text 28"/>
           <p:cNvSpPr txBox="1"/>
           <p:nvPr/>
         </p:nvSpPr>
@@ -15008,7 +16054,7 @@
       </p:sp>
       <p:sp>
         <p:nvSpPr>
-          <p:cNvPr id="13" name="Text 7"/>
+          <p:cNvPr id="34" name="Text 29"/>
           <p:cNvSpPr txBox="1"/>
           <p:nvPr/>
         </p:nvSpPr>
@@ -15050,7 +16096,7 @@
       </p:sp>
       <p:sp>
         <p:nvSpPr>
-          <p:cNvPr id="14" name="Shape 8"/>
+          <p:cNvPr id="35" name="Shape 30"/>
           <p:cNvSpPr/>
           <p:nvPr/>
         </p:nvSpPr>
@@ -15073,7 +16119,7 @@
       </p:sp>
       <p:sp>
         <p:nvSpPr>
-          <p:cNvPr id="15" name="Text 9"/>
+          <p:cNvPr id="36" name="Text 31"/>
           <p:cNvSpPr txBox="1"/>
           <p:nvPr/>
         </p:nvSpPr>
@@ -15115,7 +16161,7 @@
       </p:sp>
       <p:sp>
         <p:nvSpPr>
-          <p:cNvPr id="16" name="Text 10"/>
+          <p:cNvPr id="37" name="Text 32"/>
           <p:cNvSpPr txBox="1"/>
           <p:nvPr/>
         </p:nvSpPr>
@@ -15157,7 +16203,7 @@
       </p:sp>
       <p:sp>
         <p:nvSpPr>
-          <p:cNvPr id="17" name="Shape 11"/>
+          <p:cNvPr id="38" name="Shape 33"/>
           <p:cNvSpPr/>
           <p:nvPr/>
         </p:nvSpPr>
@@ -15180,7 +16226,7 @@
       </p:sp>
       <p:sp>
         <p:nvSpPr>
-          <p:cNvPr id="18" name="Text 12"/>
+          <p:cNvPr id="39" name="Text 34"/>
           <p:cNvSpPr txBox="1"/>
           <p:nvPr/>
         </p:nvSpPr>

</xml_diff>